<commit_message>
Slider- Install yajrabox datatable in to project
</commit_message>
<xml_diff>
--- a/.lessons/54 Slider Features/5 Slider- Install yajrabox datatable in to project/1.pptx
+++ b/.lessons/54 Slider Features/5 Slider- Install yajrabox datatable in to project/1.pptx
@@ -7,7 +7,19 @@
   <p:sldIdLst>
     <p:sldId id="413" r:id="rId2"/>
     <p:sldId id="414" r:id="rId3"/>
-    <p:sldId id="400" r:id="rId4"/>
+    <p:sldId id="415" r:id="rId4"/>
+    <p:sldId id="416" r:id="rId5"/>
+    <p:sldId id="417" r:id="rId6"/>
+    <p:sldId id="418" r:id="rId7"/>
+    <p:sldId id="419" r:id="rId8"/>
+    <p:sldId id="420" r:id="rId9"/>
+    <p:sldId id="421" r:id="rId10"/>
+    <p:sldId id="422" r:id="rId11"/>
+    <p:sldId id="424" r:id="rId12"/>
+    <p:sldId id="425" r:id="rId13"/>
+    <p:sldId id="426" r:id="rId14"/>
+    <p:sldId id="423" r:id="rId15"/>
+    <p:sldId id="400" r:id="rId16"/>
   </p:sldIdLst>
   <p:sldSz cx="12192000" cy="6858000"/>
   <p:notesSz cx="6858000" cy="9144000"/>
@@ -261,7 +273,7 @@
           <a:p>
             <a:fld id="{3E102D2E-813C-461C-9963-687A650C48C0}" type="datetimeFigureOut">
               <a:rPr lang="en-US" smtClean="0"/>
-              <a:t>6/26/2025</a:t>
+              <a:t>8/7/2025</a:t>
             </a:fld>
             <a:endParaRPr lang="en-US"/>
           </a:p>
@@ -459,7 +471,7 @@
           <a:p>
             <a:fld id="{3E102D2E-813C-461C-9963-687A650C48C0}" type="datetimeFigureOut">
               <a:rPr lang="en-US" smtClean="0"/>
-              <a:t>6/26/2025</a:t>
+              <a:t>8/7/2025</a:t>
             </a:fld>
             <a:endParaRPr lang="en-US"/>
           </a:p>
@@ -667,7 +679,7 @@
           <a:p>
             <a:fld id="{3E102D2E-813C-461C-9963-687A650C48C0}" type="datetimeFigureOut">
               <a:rPr lang="en-US" smtClean="0"/>
-              <a:t>6/26/2025</a:t>
+              <a:t>8/7/2025</a:t>
             </a:fld>
             <a:endParaRPr lang="en-US"/>
           </a:p>
@@ -865,7 +877,7 @@
           <a:p>
             <a:fld id="{3E102D2E-813C-461C-9963-687A650C48C0}" type="datetimeFigureOut">
               <a:rPr lang="en-US" smtClean="0"/>
-              <a:t>6/26/2025</a:t>
+              <a:t>8/7/2025</a:t>
             </a:fld>
             <a:endParaRPr lang="en-US"/>
           </a:p>
@@ -1140,7 +1152,7 @@
           <a:p>
             <a:fld id="{3E102D2E-813C-461C-9963-687A650C48C0}" type="datetimeFigureOut">
               <a:rPr lang="en-US" smtClean="0"/>
-              <a:t>6/26/2025</a:t>
+              <a:t>8/7/2025</a:t>
             </a:fld>
             <a:endParaRPr lang="en-US"/>
           </a:p>
@@ -1405,7 +1417,7 @@
           <a:p>
             <a:fld id="{3E102D2E-813C-461C-9963-687A650C48C0}" type="datetimeFigureOut">
               <a:rPr lang="en-US" smtClean="0"/>
-              <a:t>6/26/2025</a:t>
+              <a:t>8/7/2025</a:t>
             </a:fld>
             <a:endParaRPr lang="en-US"/>
           </a:p>
@@ -1817,7 +1829,7 @@
           <a:p>
             <a:fld id="{3E102D2E-813C-461C-9963-687A650C48C0}" type="datetimeFigureOut">
               <a:rPr lang="en-US" smtClean="0"/>
-              <a:t>6/26/2025</a:t>
+              <a:t>8/7/2025</a:t>
             </a:fld>
             <a:endParaRPr lang="en-US"/>
           </a:p>
@@ -1958,7 +1970,7 @@
           <a:p>
             <a:fld id="{3E102D2E-813C-461C-9963-687A650C48C0}" type="datetimeFigureOut">
               <a:rPr lang="en-US" smtClean="0"/>
-              <a:t>6/26/2025</a:t>
+              <a:t>8/7/2025</a:t>
             </a:fld>
             <a:endParaRPr lang="en-US"/>
           </a:p>
@@ -2071,7 +2083,7 @@
           <a:p>
             <a:fld id="{3E102D2E-813C-461C-9963-687A650C48C0}" type="datetimeFigureOut">
               <a:rPr lang="en-US" smtClean="0"/>
-              <a:t>6/26/2025</a:t>
+              <a:t>8/7/2025</a:t>
             </a:fld>
             <a:endParaRPr lang="en-US"/>
           </a:p>
@@ -2382,7 +2394,7 @@
           <a:p>
             <a:fld id="{3E102D2E-813C-461C-9963-687A650C48C0}" type="datetimeFigureOut">
               <a:rPr lang="en-US" smtClean="0"/>
-              <a:t>6/26/2025</a:t>
+              <a:t>8/7/2025</a:t>
             </a:fld>
             <a:endParaRPr lang="en-US"/>
           </a:p>
@@ -2670,7 +2682,7 @@
           <a:p>
             <a:fld id="{3E102D2E-813C-461C-9963-687A650C48C0}" type="datetimeFigureOut">
               <a:rPr lang="en-US" smtClean="0"/>
-              <a:t>6/26/2025</a:t>
+              <a:t>8/7/2025</a:t>
             </a:fld>
             <a:endParaRPr lang="en-US"/>
           </a:p>
@@ -2911,7 +2923,7 @@
           <a:p>
             <a:fld id="{3E102D2E-813C-461C-9963-687A650C48C0}" type="datetimeFigureOut">
               <a:rPr lang="en-US" smtClean="0"/>
-              <a:t>6/26/2025</a:t>
+              <a:t>8/7/2025</a:t>
             </a:fld>
             <a:endParaRPr lang="en-US"/>
           </a:p>
@@ -3349,6 +3361,429 @@
         <p:spPr>
           <a:xfrm>
             <a:off x="217714" y="255046"/>
+            <a:ext cx="11756571" cy="1255600"/>
+          </a:xfrm>
+          <a:prstGeom prst="rect">
+            <a:avLst/>
+          </a:prstGeom>
+          <a:noFill/>
+        </p:spPr>
+        <p:txBody>
+          <a:bodyPr wrap="square">
+            <a:spAutoFit/>
+          </a:bodyPr>
+          <a:lstStyle/>
+          <a:p>
+            <a:pPr>
+              <a:lnSpc>
+                <a:spcPct val="150000"/>
+              </a:lnSpc>
+              <a:buNone/>
+            </a:pPr>
+            <a:r>
+              <a:rPr lang="az-Latn-AZ" altLang="en-US" sz="1300">
+                <a:latin typeface="Arial" panose="020B0604020202020204" pitchFamily="34" charset="0"/>
+              </a:rPr>
+              <a:t>İndi `</a:t>
+            </a:r>
+            <a:r>
+              <a:rPr lang="az-Latn-AZ" altLang="en-US" sz="1300" b="1">
+                <a:latin typeface="Arial" panose="020B0604020202020204" pitchFamily="34" charset="0"/>
+              </a:rPr>
+              <a:t>yajrabox</a:t>
+            </a:r>
+            <a:r>
+              <a:rPr lang="az-Latn-AZ" altLang="en-US" sz="1300">
+                <a:latin typeface="Arial" panose="020B0604020202020204" pitchFamily="34" charset="0"/>
+              </a:rPr>
+              <a:t>` paketini qururuq: </a:t>
+            </a:r>
+            <a:r>
+              <a:rPr lang="az-Latn-AZ" altLang="en-US" sz="1300" b="1" u="sng">
+                <a:solidFill>
+                  <a:srgbClr val="0070C0"/>
+                </a:solidFill>
+                <a:latin typeface="Arial" panose="020B0604020202020204" pitchFamily="34" charset="0"/>
+              </a:rPr>
+              <a:t>https://yajrabox.com/docs/laravel-datatables/10.0/quick-starter</a:t>
+            </a:r>
+          </a:p>
+          <a:p>
+            <a:pPr>
+              <a:lnSpc>
+                <a:spcPct val="150000"/>
+              </a:lnSpc>
+              <a:buNone/>
+            </a:pPr>
+            <a:endParaRPr kumimoji="0" lang="az-Latn-AZ" altLang="en-US" sz="1300" b="0" i="0" u="none" strike="noStrike" cap="none" normalizeH="0" baseline="0">
+              <a:ln>
+                <a:noFill/>
+              </a:ln>
+              <a:solidFill>
+                <a:schemeClr val="tx1"/>
+              </a:solidFill>
+              <a:effectLst/>
+              <a:latin typeface="Arial" panose="020B0604020202020204" pitchFamily="34" charset="0"/>
+            </a:endParaRPr>
+          </a:p>
+          <a:p>
+            <a:pPr>
+              <a:lnSpc>
+                <a:spcPct val="150000"/>
+              </a:lnSpc>
+              <a:buNone/>
+            </a:pPr>
+            <a:endParaRPr lang="az-Latn-AZ" altLang="en-US" sz="1300">
+              <a:latin typeface="Arial" panose="020B0604020202020204" pitchFamily="34" charset="0"/>
+            </a:endParaRPr>
+          </a:p>
+          <a:p>
+            <a:pPr>
+              <a:lnSpc>
+                <a:spcPct val="150000"/>
+              </a:lnSpc>
+              <a:buNone/>
+            </a:pPr>
+            <a:r>
+              <a:rPr lang="az-Latn-AZ" altLang="en-US" sz="1300">
+                <a:latin typeface="Arial" panose="020B0604020202020204" pitchFamily="34" charset="0"/>
+              </a:rPr>
+              <a:t>Bu paket haqqında əvvəl dərsimiz olubdur. İndiki dərsdə isə, həmin bu paketin `</a:t>
+            </a:r>
+            <a:r>
+              <a:rPr lang="az-Latn-AZ" altLang="en-US" sz="1300" b="1">
+                <a:latin typeface="Arial" panose="020B0604020202020204" pitchFamily="34" charset="0"/>
+              </a:rPr>
+              <a:t>datatables.net</a:t>
+            </a:r>
+            <a:r>
+              <a:rPr lang="az-Latn-AZ" altLang="en-US" sz="1300">
+                <a:latin typeface="Arial" panose="020B0604020202020204" pitchFamily="34" charset="0"/>
+              </a:rPr>
+              <a:t>` ilə olan əlaqəsini və istifadəsini görəcəyik.</a:t>
+            </a:r>
+            <a:endParaRPr kumimoji="0" lang="en-US" altLang="en-US" sz="1300" b="0" i="0" u="none" strike="noStrike" cap="none" normalizeH="0" baseline="0">
+              <a:ln>
+                <a:noFill/>
+              </a:ln>
+              <a:solidFill>
+                <a:schemeClr val="tx1"/>
+              </a:solidFill>
+              <a:effectLst/>
+              <a:latin typeface="Arial" panose="020B0604020202020204" pitchFamily="34" charset="0"/>
+            </a:endParaRPr>
+          </a:p>
+        </p:txBody>
+      </p:sp>
+      <p:pic>
+        <p:nvPicPr>
+          <p:cNvPr id="4" name="Picture 3">
+            <a:extLst>
+              <a:ext uri="{FF2B5EF4-FFF2-40B4-BE49-F238E27FC236}">
+                <a16:creationId xmlns:a16="http://schemas.microsoft.com/office/drawing/2014/main" id="{F308EB91-9670-69B2-2412-66CAF75E94C7}"/>
+              </a:ext>
+            </a:extLst>
+          </p:cNvPr>
+          <p:cNvPicPr>
+            <a:picLocks noChangeAspect="1"/>
+          </p:cNvPicPr>
+          <p:nvPr/>
+        </p:nvPicPr>
+        <p:blipFill>
+          <a:blip r:embed="rId2"/>
+          <a:stretch>
+            <a:fillRect/>
+          </a:stretch>
+        </p:blipFill>
+        <p:spPr>
+          <a:xfrm>
+            <a:off x="-1" y="1744610"/>
+            <a:ext cx="12192000" cy="5113390"/>
+          </a:xfrm>
+          <a:prstGeom prst="rect">
+            <a:avLst/>
+          </a:prstGeom>
+        </p:spPr>
+      </p:pic>
+    </p:spTree>
+    <p:extLst>
+      <p:ext uri="{BB962C8B-B14F-4D97-AF65-F5344CB8AC3E}">
+        <p14:creationId xmlns:p14="http://schemas.microsoft.com/office/powerpoint/2010/main" val="3863838039"/>
+      </p:ext>
+    </p:extLst>
+  </p:cSld>
+  <p:clrMapOvr>
+    <a:masterClrMapping/>
+  </p:clrMapOvr>
+</p:sld>
+</file>
+
+<file path=ppt/slides/slide10.xml><?xml version="1.0" encoding="utf-8"?>
+<p:sld xmlns:a="http://schemas.openxmlformats.org/drawingml/2006/main" xmlns:r="http://schemas.openxmlformats.org/officeDocument/2006/relationships" xmlns:p="http://schemas.openxmlformats.org/presentationml/2006/main">
+  <p:cSld>
+    <p:spTree>
+      <p:nvGrpSpPr>
+        <p:cNvPr id="1" name="">
+          <a:extLst>
+            <a:ext uri="{FF2B5EF4-FFF2-40B4-BE49-F238E27FC236}">
+              <a16:creationId xmlns:a16="http://schemas.microsoft.com/office/drawing/2014/main" id="{A4CE0392-D461-1398-BE77-C5F8774A5D3F}"/>
+            </a:ext>
+          </a:extLst>
+        </p:cNvPr>
+        <p:cNvGrpSpPr/>
+        <p:nvPr/>
+      </p:nvGrpSpPr>
+      <p:grpSpPr>
+        <a:xfrm>
+          <a:off x="0" y="0"/>
+          <a:ext cx="0" cy="0"/>
+          <a:chOff x="0" y="0"/>
+          <a:chExt cx="0" cy="0"/>
+        </a:xfrm>
+      </p:grpSpPr>
+      <p:sp>
+        <p:nvSpPr>
+          <p:cNvPr id="3" name="TextBox 2">
+            <a:extLst>
+              <a:ext uri="{FF2B5EF4-FFF2-40B4-BE49-F238E27FC236}">
+                <a16:creationId xmlns:a16="http://schemas.microsoft.com/office/drawing/2014/main" id="{D5EB228C-872F-FD40-5271-ACF50F712549}"/>
+              </a:ext>
+            </a:extLst>
+          </p:cNvPr>
+          <p:cNvSpPr txBox="1"/>
+          <p:nvPr/>
+        </p:nvSpPr>
+        <p:spPr>
+          <a:xfrm>
+            <a:off x="217714" y="255046"/>
+            <a:ext cx="11756571" cy="464871"/>
+          </a:xfrm>
+          <a:prstGeom prst="rect">
+            <a:avLst/>
+          </a:prstGeom>
+          <a:noFill/>
+        </p:spPr>
+        <p:txBody>
+          <a:bodyPr wrap="square">
+            <a:spAutoFit/>
+          </a:bodyPr>
+          <a:lstStyle/>
+          <a:p>
+            <a:pPr>
+              <a:lnSpc>
+                <a:spcPct val="150000"/>
+              </a:lnSpc>
+            </a:pPr>
+            <a:r>
+              <a:rPr lang="az-Latn-AZ" altLang="en-US" sz="1300">
+                <a:latin typeface="Arial" panose="020B0604020202020204" pitchFamily="34" charset="0"/>
+              </a:rPr>
+              <a:t>Sadəcə versiyanı aşağı salmaq lazımdır: </a:t>
+            </a:r>
+            <a:r>
+              <a:rPr lang="en-US"/>
+              <a:t>  &lt;script src="https://cdn.datatables.net/1.13.4/js/dataTables.bootstrap5.js"&gt;&lt;/script&gt;</a:t>
+            </a:r>
+          </a:p>
+        </p:txBody>
+      </p:sp>
+      <p:pic>
+        <p:nvPicPr>
+          <p:cNvPr id="4" name="Picture 3">
+            <a:extLst>
+              <a:ext uri="{FF2B5EF4-FFF2-40B4-BE49-F238E27FC236}">
+                <a16:creationId xmlns:a16="http://schemas.microsoft.com/office/drawing/2014/main" id="{C823AFB9-268E-750A-C14D-F762D4298D0C}"/>
+              </a:ext>
+            </a:extLst>
+          </p:cNvPr>
+          <p:cNvPicPr>
+            <a:picLocks noChangeAspect="1"/>
+          </p:cNvPicPr>
+          <p:nvPr/>
+        </p:nvPicPr>
+        <p:blipFill>
+          <a:blip r:embed="rId2"/>
+          <a:stretch>
+            <a:fillRect/>
+          </a:stretch>
+        </p:blipFill>
+        <p:spPr>
+          <a:xfrm>
+            <a:off x="3236719" y="1237673"/>
+            <a:ext cx="8955281" cy="5620327"/>
+          </a:xfrm>
+          <a:prstGeom prst="rect">
+            <a:avLst/>
+          </a:prstGeom>
+        </p:spPr>
+      </p:pic>
+    </p:spTree>
+    <p:extLst>
+      <p:ext uri="{BB962C8B-B14F-4D97-AF65-F5344CB8AC3E}">
+        <p14:creationId xmlns:p14="http://schemas.microsoft.com/office/powerpoint/2010/main" val="2169341366"/>
+      </p:ext>
+    </p:extLst>
+  </p:cSld>
+  <p:clrMapOvr>
+    <a:masterClrMapping/>
+  </p:clrMapOvr>
+</p:sld>
+</file>
+
+<file path=ppt/slides/slide11.xml><?xml version="1.0" encoding="utf-8"?>
+<p:sld xmlns:a="http://schemas.openxmlformats.org/drawingml/2006/main" xmlns:r="http://schemas.openxmlformats.org/officeDocument/2006/relationships" xmlns:p="http://schemas.openxmlformats.org/presentationml/2006/main">
+  <p:cSld>
+    <p:spTree>
+      <p:nvGrpSpPr>
+        <p:cNvPr id="1" name="">
+          <a:extLst>
+            <a:ext uri="{FF2B5EF4-FFF2-40B4-BE49-F238E27FC236}">
+              <a16:creationId xmlns:a16="http://schemas.microsoft.com/office/drawing/2014/main" id="{D54D846D-B736-0920-BE94-6F775B04B9CB}"/>
+            </a:ext>
+          </a:extLst>
+        </p:cNvPr>
+        <p:cNvGrpSpPr/>
+        <p:nvPr/>
+      </p:nvGrpSpPr>
+      <p:grpSpPr>
+        <a:xfrm>
+          <a:off x="0" y="0"/>
+          <a:ext cx="0" cy="0"/>
+          <a:chOff x="0" y="0"/>
+          <a:chExt cx="0" cy="0"/>
+        </a:xfrm>
+      </p:grpSpPr>
+      <p:sp>
+        <p:nvSpPr>
+          <p:cNvPr id="3" name="TextBox 2">
+            <a:extLst>
+              <a:ext uri="{FF2B5EF4-FFF2-40B4-BE49-F238E27FC236}">
+                <a16:creationId xmlns:a16="http://schemas.microsoft.com/office/drawing/2014/main" id="{3F586896-5E5F-CA5F-2F1B-8F569B607178}"/>
+              </a:ext>
+            </a:extLst>
+          </p:cNvPr>
+          <p:cNvSpPr txBox="1"/>
+          <p:nvPr/>
+        </p:nvSpPr>
+        <p:spPr>
+          <a:xfrm>
+            <a:off x="217714" y="255046"/>
+            <a:ext cx="11756571" cy="464871"/>
+          </a:xfrm>
+          <a:prstGeom prst="rect">
+            <a:avLst/>
+          </a:prstGeom>
+          <a:noFill/>
+        </p:spPr>
+        <p:txBody>
+          <a:bodyPr wrap="square">
+            <a:spAutoFit/>
+          </a:bodyPr>
+          <a:lstStyle/>
+          <a:p>
+            <a:pPr>
+              <a:lnSpc>
+                <a:spcPct val="150000"/>
+              </a:lnSpc>
+            </a:pPr>
+            <a:r>
+              <a:rPr lang="az-Latn-AZ" altLang="en-US" sz="1100">
+                <a:latin typeface="Arial" panose="020B0604020202020204" pitchFamily="34" charset="0"/>
+              </a:rPr>
+              <a:t>Sadəcə versiyanı aşağı salmaq lazımdır: </a:t>
+            </a:r>
+            <a:r>
+              <a:rPr lang="en-US" sz="1400"/>
+              <a:t>  </a:t>
+            </a:r>
+            <a:r>
+              <a:rPr lang="en-US"/>
+              <a:t>&lt;link rel="stylesheet" href="https://cdn.datatables.net/1.13.4/css/dataTables.bootstrap5.css"&gt;</a:t>
+            </a:r>
+          </a:p>
+        </p:txBody>
+      </p:sp>
+      <p:pic>
+        <p:nvPicPr>
+          <p:cNvPr id="4" name="Picture 3">
+            <a:extLst>
+              <a:ext uri="{FF2B5EF4-FFF2-40B4-BE49-F238E27FC236}">
+                <a16:creationId xmlns:a16="http://schemas.microsoft.com/office/drawing/2014/main" id="{C2FDA1E5-2552-846B-8695-C99C228C9100}"/>
+              </a:ext>
+            </a:extLst>
+          </p:cNvPr>
+          <p:cNvPicPr>
+            <a:picLocks noChangeAspect="1"/>
+          </p:cNvPicPr>
+          <p:nvPr/>
+        </p:nvPicPr>
+        <p:blipFill>
+          <a:blip r:embed="rId2"/>
+          <a:stretch>
+            <a:fillRect/>
+          </a:stretch>
+        </p:blipFill>
+        <p:spPr>
+          <a:xfrm>
+            <a:off x="2530764" y="1057722"/>
+            <a:ext cx="9661236" cy="5800278"/>
+          </a:xfrm>
+          <a:prstGeom prst="rect">
+            <a:avLst/>
+          </a:prstGeom>
+        </p:spPr>
+      </p:pic>
+    </p:spTree>
+    <p:extLst>
+      <p:ext uri="{BB962C8B-B14F-4D97-AF65-F5344CB8AC3E}">
+        <p14:creationId xmlns:p14="http://schemas.microsoft.com/office/powerpoint/2010/main" val="2984003938"/>
+      </p:ext>
+    </p:extLst>
+  </p:cSld>
+  <p:clrMapOvr>
+    <a:masterClrMapping/>
+  </p:clrMapOvr>
+</p:sld>
+</file>
+
+<file path=ppt/slides/slide12.xml><?xml version="1.0" encoding="utf-8"?>
+<p:sld xmlns:a="http://schemas.openxmlformats.org/drawingml/2006/main" xmlns:r="http://schemas.openxmlformats.org/officeDocument/2006/relationships" xmlns:p="http://schemas.openxmlformats.org/presentationml/2006/main">
+  <p:cSld>
+    <p:spTree>
+      <p:nvGrpSpPr>
+        <p:cNvPr id="1" name="">
+          <a:extLst>
+            <a:ext uri="{FF2B5EF4-FFF2-40B4-BE49-F238E27FC236}">
+              <a16:creationId xmlns:a16="http://schemas.microsoft.com/office/drawing/2014/main" id="{0E8F0257-516B-637D-91E5-2B8C3A822891}"/>
+            </a:ext>
+          </a:extLst>
+        </p:cNvPr>
+        <p:cNvGrpSpPr/>
+        <p:nvPr/>
+      </p:nvGrpSpPr>
+      <p:grpSpPr>
+        <a:xfrm>
+          <a:off x="0" y="0"/>
+          <a:ext cx="0" cy="0"/>
+          <a:chOff x="0" y="0"/>
+          <a:chExt cx="0" cy="0"/>
+        </a:xfrm>
+      </p:grpSpPr>
+      <p:sp>
+        <p:nvSpPr>
+          <p:cNvPr id="3" name="TextBox 2">
+            <a:extLst>
+              <a:ext uri="{FF2B5EF4-FFF2-40B4-BE49-F238E27FC236}">
+                <a16:creationId xmlns:a16="http://schemas.microsoft.com/office/drawing/2014/main" id="{8ACB0906-F7F9-14EF-45D1-E1BEE272EB2C}"/>
+              </a:ext>
+            </a:extLst>
+          </p:cNvPr>
+          <p:cNvSpPr txBox="1"/>
+          <p:nvPr/>
+        </p:nvSpPr>
+        <p:spPr>
+          <a:xfrm>
+            <a:off x="217714" y="255046"/>
             <a:ext cx="11756571" cy="355354"/>
           </a:xfrm>
           <a:prstGeom prst="rect">
@@ -3384,10 +3819,345 @@
           </a:p>
         </p:txBody>
       </p:sp>
+      <p:pic>
+        <p:nvPicPr>
+          <p:cNvPr id="4" name="Picture 3">
+            <a:extLst>
+              <a:ext uri="{FF2B5EF4-FFF2-40B4-BE49-F238E27FC236}">
+                <a16:creationId xmlns:a16="http://schemas.microsoft.com/office/drawing/2014/main" id="{22C7B97F-031D-758B-06AC-02CBD69DEF51}"/>
+              </a:ext>
+            </a:extLst>
+          </p:cNvPr>
+          <p:cNvPicPr>
+            <a:picLocks noChangeAspect="1"/>
+          </p:cNvPicPr>
+          <p:nvPr/>
+        </p:nvPicPr>
+        <p:blipFill>
+          <a:blip r:embed="rId2"/>
+          <a:stretch>
+            <a:fillRect/>
+          </a:stretch>
+        </p:blipFill>
+        <p:spPr>
+          <a:xfrm>
+            <a:off x="3468117" y="0"/>
+            <a:ext cx="8723883" cy="6858000"/>
+          </a:xfrm>
+          <a:prstGeom prst="rect">
+            <a:avLst/>
+          </a:prstGeom>
+        </p:spPr>
+      </p:pic>
     </p:spTree>
     <p:extLst>
       <p:ext uri="{BB962C8B-B14F-4D97-AF65-F5344CB8AC3E}">
-        <p14:creationId xmlns:p14="http://schemas.microsoft.com/office/powerpoint/2010/main" val="3863838039"/>
+        <p14:creationId xmlns:p14="http://schemas.microsoft.com/office/powerpoint/2010/main" val="1168208726"/>
+      </p:ext>
+    </p:extLst>
+  </p:cSld>
+  <p:clrMapOvr>
+    <a:masterClrMapping/>
+  </p:clrMapOvr>
+</p:sld>
+</file>
+
+<file path=ppt/slides/slide13.xml><?xml version="1.0" encoding="utf-8"?>
+<p:sld xmlns:a="http://schemas.openxmlformats.org/drawingml/2006/main" xmlns:r="http://schemas.openxmlformats.org/officeDocument/2006/relationships" xmlns:p="http://schemas.openxmlformats.org/presentationml/2006/main">
+  <p:cSld>
+    <p:spTree>
+      <p:nvGrpSpPr>
+        <p:cNvPr id="1" name="">
+          <a:extLst>
+            <a:ext uri="{FF2B5EF4-FFF2-40B4-BE49-F238E27FC236}">
+              <a16:creationId xmlns:a16="http://schemas.microsoft.com/office/drawing/2014/main" id="{DE20034D-D4EF-2943-5E06-5B546CD4161F}"/>
+            </a:ext>
+          </a:extLst>
+        </p:cNvPr>
+        <p:cNvGrpSpPr/>
+        <p:nvPr/>
+      </p:nvGrpSpPr>
+      <p:grpSpPr>
+        <a:xfrm>
+          <a:off x="0" y="0"/>
+          <a:ext cx="0" cy="0"/>
+          <a:chOff x="0" y="0"/>
+          <a:chExt cx="0" cy="0"/>
+        </a:xfrm>
+      </p:grpSpPr>
+      <p:sp>
+        <p:nvSpPr>
+          <p:cNvPr id="3" name="TextBox 2">
+            <a:extLst>
+              <a:ext uri="{FF2B5EF4-FFF2-40B4-BE49-F238E27FC236}">
+                <a16:creationId xmlns:a16="http://schemas.microsoft.com/office/drawing/2014/main" id="{1B275747-5AF3-87DF-3DBF-A0241CB63BA9}"/>
+              </a:ext>
+            </a:extLst>
+          </p:cNvPr>
+          <p:cNvSpPr txBox="1"/>
+          <p:nvPr/>
+        </p:nvSpPr>
+        <p:spPr>
+          <a:xfrm>
+            <a:off x="217714" y="255046"/>
+            <a:ext cx="11756571" cy="355354"/>
+          </a:xfrm>
+          <a:prstGeom prst="rect">
+            <a:avLst/>
+          </a:prstGeom>
+          <a:noFill/>
+        </p:spPr>
+        <p:txBody>
+          <a:bodyPr wrap="square">
+            <a:spAutoFit/>
+          </a:bodyPr>
+          <a:lstStyle/>
+          <a:p>
+            <a:pPr>
+              <a:lnSpc>
+                <a:spcPct val="150000"/>
+              </a:lnSpc>
+              <a:buNone/>
+            </a:pPr>
+            <a:r>
+              <a:rPr lang="az-Latn-AZ" altLang="en-US" sz="1300">
+                <a:latin typeface="Arial" panose="020B0604020202020204" pitchFamily="34" charset="0"/>
+              </a:rPr>
+              <a:t>Nəticə.</a:t>
+            </a:r>
+            <a:endParaRPr kumimoji="0" lang="en-US" altLang="en-US" sz="1300" b="0" i="0" u="none" strike="noStrike" cap="none" normalizeH="0" baseline="0">
+              <a:ln>
+                <a:noFill/>
+              </a:ln>
+              <a:solidFill>
+                <a:schemeClr val="tx1"/>
+              </a:solidFill>
+              <a:effectLst/>
+              <a:latin typeface="Arial" panose="020B0604020202020204" pitchFamily="34" charset="0"/>
+            </a:endParaRPr>
+          </a:p>
+        </p:txBody>
+      </p:sp>
+      <p:pic>
+        <p:nvPicPr>
+          <p:cNvPr id="4" name="Picture 3">
+            <a:extLst>
+              <a:ext uri="{FF2B5EF4-FFF2-40B4-BE49-F238E27FC236}">
+                <a16:creationId xmlns:a16="http://schemas.microsoft.com/office/drawing/2014/main" id="{3E05D1DE-C100-0C26-FC3B-752E905BA8EA}"/>
+              </a:ext>
+            </a:extLst>
+          </p:cNvPr>
+          <p:cNvPicPr>
+            <a:picLocks noChangeAspect="1"/>
+          </p:cNvPicPr>
+          <p:nvPr/>
+        </p:nvPicPr>
+        <p:blipFill>
+          <a:blip r:embed="rId2"/>
+          <a:stretch>
+            <a:fillRect/>
+          </a:stretch>
+        </p:blipFill>
+        <p:spPr>
+          <a:xfrm>
+            <a:off x="0" y="2634553"/>
+            <a:ext cx="12192000" cy="4140319"/>
+          </a:xfrm>
+          <a:prstGeom prst="rect">
+            <a:avLst/>
+          </a:prstGeom>
+          <a:ln w="38100" cap="sq">
+            <a:solidFill>
+              <a:srgbClr val="000000"/>
+            </a:solidFill>
+            <a:prstDash val="solid"/>
+            <a:miter lim="800000"/>
+          </a:ln>
+          <a:effectLst>
+            <a:outerShdw blurRad="50800" dist="38100" dir="2700000" algn="tl" rotWithShape="0">
+              <a:srgbClr val="000000">
+                <a:alpha val="43000"/>
+              </a:srgbClr>
+            </a:outerShdw>
+          </a:effectLst>
+        </p:spPr>
+      </p:pic>
+    </p:spTree>
+    <p:extLst>
+      <p:ext uri="{BB962C8B-B14F-4D97-AF65-F5344CB8AC3E}">
+        <p14:creationId xmlns:p14="http://schemas.microsoft.com/office/powerpoint/2010/main" val="157967518"/>
+      </p:ext>
+    </p:extLst>
+  </p:cSld>
+  <p:clrMapOvr>
+    <a:masterClrMapping/>
+  </p:clrMapOvr>
+</p:sld>
+</file>
+
+<file path=ppt/slides/slide14.xml><?xml version="1.0" encoding="utf-8"?>
+<p:sld xmlns:a="http://schemas.openxmlformats.org/drawingml/2006/main" xmlns:r="http://schemas.openxmlformats.org/officeDocument/2006/relationships" xmlns:p="http://schemas.openxmlformats.org/presentationml/2006/main">
+  <p:cSld>
+    <p:spTree>
+      <p:nvGrpSpPr>
+        <p:cNvPr id="1" name="">
+          <a:extLst>
+            <a:ext uri="{FF2B5EF4-FFF2-40B4-BE49-F238E27FC236}">
+              <a16:creationId xmlns:a16="http://schemas.microsoft.com/office/drawing/2014/main" id="{CA8517DD-F0B5-3506-19E5-DF48A5ECB15E}"/>
+            </a:ext>
+          </a:extLst>
+        </p:cNvPr>
+        <p:cNvGrpSpPr/>
+        <p:nvPr/>
+      </p:nvGrpSpPr>
+      <p:grpSpPr>
+        <a:xfrm>
+          <a:off x="0" y="0"/>
+          <a:ext cx="0" cy="0"/>
+          <a:chOff x="0" y="0"/>
+          <a:chExt cx="0" cy="0"/>
+        </a:xfrm>
+      </p:grpSpPr>
+      <p:sp>
+        <p:nvSpPr>
+          <p:cNvPr id="3" name="TextBox 2">
+            <a:extLst>
+              <a:ext uri="{FF2B5EF4-FFF2-40B4-BE49-F238E27FC236}">
+                <a16:creationId xmlns:a16="http://schemas.microsoft.com/office/drawing/2014/main" id="{0D33BE53-EF96-4817-487D-5154A4DA27DD}"/>
+              </a:ext>
+            </a:extLst>
+          </p:cNvPr>
+          <p:cNvSpPr txBox="1"/>
+          <p:nvPr/>
+        </p:nvSpPr>
+        <p:spPr>
+          <a:xfrm>
+            <a:off x="217714" y="255046"/>
+            <a:ext cx="11756571" cy="355354"/>
+          </a:xfrm>
+          <a:prstGeom prst="rect">
+            <a:avLst/>
+          </a:prstGeom>
+          <a:noFill/>
+        </p:spPr>
+        <p:txBody>
+          <a:bodyPr wrap="square">
+            <a:spAutoFit/>
+          </a:bodyPr>
+          <a:lstStyle/>
+          <a:p>
+            <a:pPr>
+              <a:lnSpc>
+                <a:spcPct val="150000"/>
+              </a:lnSpc>
+              <a:buNone/>
+            </a:pPr>
+            <a:r>
+              <a:rPr kumimoji="0" lang="en-US" altLang="en-US" sz="1300" b="0" i="0" u="none" strike="noStrike" cap="none" normalizeH="0" baseline="0">
+                <a:ln>
+                  <a:noFill/>
+                </a:ln>
+                <a:solidFill>
+                  <a:schemeClr val="tx1"/>
+                </a:solidFill>
+                <a:effectLst/>
+                <a:latin typeface="Arial" panose="020B0604020202020204" pitchFamily="34" charset="0"/>
+              </a:rPr>
+              <a:t>.</a:t>
+            </a:r>
+          </a:p>
+        </p:txBody>
+      </p:sp>
+    </p:spTree>
+    <p:extLst>
+      <p:ext uri="{BB962C8B-B14F-4D97-AF65-F5344CB8AC3E}">
+        <p14:creationId xmlns:p14="http://schemas.microsoft.com/office/powerpoint/2010/main" val="1671762836"/>
+      </p:ext>
+    </p:extLst>
+  </p:cSld>
+  <p:clrMapOvr>
+    <a:masterClrMapping/>
+  </p:clrMapOvr>
+</p:sld>
+</file>
+
+<file path=ppt/slides/slide15.xml><?xml version="1.0" encoding="utf-8"?>
+<p:sld xmlns:a="http://schemas.openxmlformats.org/drawingml/2006/main" xmlns:r="http://schemas.openxmlformats.org/officeDocument/2006/relationships" xmlns:p="http://schemas.openxmlformats.org/presentationml/2006/main">
+  <p:cSld>
+    <p:spTree>
+      <p:nvGrpSpPr>
+        <p:cNvPr id="1" name="">
+          <a:extLst>
+            <a:ext uri="{FF2B5EF4-FFF2-40B4-BE49-F238E27FC236}">
+              <a16:creationId xmlns:a16="http://schemas.microsoft.com/office/drawing/2014/main" id="{ECE25D7D-A080-F22B-7E8D-36EC827289A1}"/>
+            </a:ext>
+          </a:extLst>
+        </p:cNvPr>
+        <p:cNvGrpSpPr/>
+        <p:nvPr/>
+      </p:nvGrpSpPr>
+      <p:grpSpPr>
+        <a:xfrm>
+          <a:off x="0" y="0"/>
+          <a:ext cx="0" cy="0"/>
+          <a:chOff x="0" y="0"/>
+          <a:chExt cx="0" cy="0"/>
+        </a:xfrm>
+      </p:grpSpPr>
+      <p:sp>
+        <p:nvSpPr>
+          <p:cNvPr id="3" name="TextBox 2">
+            <a:extLst>
+              <a:ext uri="{FF2B5EF4-FFF2-40B4-BE49-F238E27FC236}">
+                <a16:creationId xmlns:a16="http://schemas.microsoft.com/office/drawing/2014/main" id="{E33F16A3-A6E8-401E-847B-09570DC6E4CB}"/>
+              </a:ext>
+            </a:extLst>
+          </p:cNvPr>
+          <p:cNvSpPr txBox="1"/>
+          <p:nvPr/>
+        </p:nvSpPr>
+        <p:spPr>
+          <a:xfrm>
+            <a:off x="217714" y="255046"/>
+            <a:ext cx="11756571" cy="355354"/>
+          </a:xfrm>
+          <a:prstGeom prst="rect">
+            <a:avLst/>
+          </a:prstGeom>
+          <a:noFill/>
+        </p:spPr>
+        <p:txBody>
+          <a:bodyPr wrap="square">
+            <a:spAutoFit/>
+          </a:bodyPr>
+          <a:lstStyle/>
+          <a:p>
+            <a:pPr>
+              <a:lnSpc>
+                <a:spcPct val="150000"/>
+              </a:lnSpc>
+              <a:buNone/>
+            </a:pPr>
+            <a:r>
+              <a:rPr kumimoji="0" lang="en-US" altLang="en-US" sz="1300" b="0" i="0" u="none" strike="noStrike" cap="none" normalizeH="0" baseline="0">
+                <a:ln>
+                  <a:noFill/>
+                </a:ln>
+                <a:solidFill>
+                  <a:schemeClr val="tx1"/>
+                </a:solidFill>
+                <a:effectLst/>
+                <a:latin typeface="Arial" panose="020B0604020202020204" pitchFamily="34" charset="0"/>
+              </a:rPr>
+              <a:t>.</a:t>
+            </a:r>
+          </a:p>
+        </p:txBody>
+      </p:sp>
+    </p:spTree>
+    <p:extLst>
+      <p:ext uri="{BB962C8B-B14F-4D97-AF65-F5344CB8AC3E}">
+        <p14:creationId xmlns:p14="http://schemas.microsoft.com/office/powerpoint/2010/main" val="3095838342"/>
       </p:ext>
     </p:extLst>
   </p:cSld>
@@ -3455,18 +4225,169 @@
               <a:buNone/>
             </a:pPr>
             <a:r>
-              <a:rPr kumimoji="0" lang="en-US" altLang="en-US" sz="1300" b="0" i="0" u="none" strike="noStrike" cap="none" normalizeH="0" baseline="0">
-                <a:ln>
-                  <a:noFill/>
-                </a:ln>
-                <a:solidFill>
-                  <a:schemeClr val="tx1"/>
-                </a:solidFill>
-                <a:effectLst/>
-                <a:latin typeface="Arial" panose="020B0604020202020204" pitchFamily="34" charset="0"/>
-              </a:rPr>
-              <a:t>.</a:t>
-            </a:r>
+              <a:rPr lang="en-US" altLang="en-US" sz="1300">
+                <a:latin typeface="Arial" panose="020B0604020202020204" pitchFamily="34" charset="0"/>
+              </a:rPr>
+              <a:t>"</a:t>
+            </a:r>
+            <a:r>
+              <a:rPr lang="en-US" altLang="en-US" sz="1300" b="1">
+                <a:latin typeface="Arial" panose="020B0604020202020204" pitchFamily="34" charset="0"/>
+              </a:rPr>
+              <a:t>Composer require</a:t>
+            </a:r>
+            <a:r>
+              <a:rPr lang="en-US" altLang="en-US" sz="1300">
+                <a:latin typeface="Arial" panose="020B0604020202020204" pitchFamily="34" charset="0"/>
+              </a:rPr>
+              <a:t>" komandası </a:t>
+            </a:r>
+            <a:r>
+              <a:rPr lang="az-Latn-AZ" altLang="en-US" sz="1300">
+                <a:latin typeface="Arial" panose="020B0604020202020204" pitchFamily="34" charset="0"/>
+              </a:rPr>
+              <a:t>ilə, `</a:t>
+            </a:r>
+            <a:r>
+              <a:rPr lang="az-Latn-AZ" altLang="en-US" sz="1300" b="1">
+                <a:latin typeface="Arial" panose="020B0604020202020204" pitchFamily="34" charset="0"/>
+              </a:rPr>
+              <a:t>yajrabox</a:t>
+            </a:r>
+            <a:r>
+              <a:rPr lang="az-Latn-AZ" altLang="en-US" sz="1300">
+                <a:latin typeface="Arial" panose="020B0604020202020204" pitchFamily="34" charset="0"/>
+              </a:rPr>
+              <a:t>` paketini </a:t>
+            </a:r>
+            <a:r>
+              <a:rPr lang="en-US" altLang="en-US" sz="1300">
+                <a:latin typeface="Arial" panose="020B0604020202020204" pitchFamily="34" charset="0"/>
+              </a:rPr>
+              <a:t>layihəyə əlavə edir</a:t>
+            </a:r>
+            <a:r>
+              <a:rPr lang="az-Latn-AZ" altLang="en-US" sz="1300">
+                <a:latin typeface="Arial" panose="020B0604020202020204" pitchFamily="34" charset="0"/>
+              </a:rPr>
+              <a:t>ik.</a:t>
+            </a:r>
+            <a:endParaRPr kumimoji="0" lang="en-US" altLang="en-US" sz="1300" b="0" i="0" u="none" strike="noStrike" cap="none" normalizeH="0" baseline="0">
+              <a:ln>
+                <a:noFill/>
+              </a:ln>
+              <a:solidFill>
+                <a:schemeClr val="tx1"/>
+              </a:solidFill>
+              <a:effectLst/>
+              <a:latin typeface="Arial" panose="020B0604020202020204" pitchFamily="34" charset="0"/>
+            </a:endParaRPr>
+          </a:p>
+        </p:txBody>
+      </p:sp>
+      <p:pic>
+        <p:nvPicPr>
+          <p:cNvPr id="4" name="Picture 3">
+            <a:extLst>
+              <a:ext uri="{FF2B5EF4-FFF2-40B4-BE49-F238E27FC236}">
+                <a16:creationId xmlns:a16="http://schemas.microsoft.com/office/drawing/2014/main" id="{66037D17-57AA-2AD1-66FC-677C7ED01DA2}"/>
+              </a:ext>
+            </a:extLst>
+          </p:cNvPr>
+          <p:cNvPicPr>
+            <a:picLocks noChangeAspect="1"/>
+          </p:cNvPicPr>
+          <p:nvPr/>
+        </p:nvPicPr>
+        <p:blipFill>
+          <a:blip r:embed="rId2"/>
+          <a:stretch>
+            <a:fillRect/>
+          </a:stretch>
+        </p:blipFill>
+        <p:spPr>
+          <a:xfrm>
+            <a:off x="-1" y="1051230"/>
+            <a:ext cx="12192000" cy="3259248"/>
+          </a:xfrm>
+          <a:prstGeom prst="rect">
+            <a:avLst/>
+          </a:prstGeom>
+        </p:spPr>
+      </p:pic>
+      <p:pic>
+        <p:nvPicPr>
+          <p:cNvPr id="6" name="Picture 5">
+            <a:extLst>
+              <a:ext uri="{FF2B5EF4-FFF2-40B4-BE49-F238E27FC236}">
+                <a16:creationId xmlns:a16="http://schemas.microsoft.com/office/drawing/2014/main" id="{FC68C236-E0BB-0A08-69FF-793E2DA3445F}"/>
+              </a:ext>
+            </a:extLst>
+          </p:cNvPr>
+          <p:cNvPicPr>
+            <a:picLocks noChangeAspect="1"/>
+          </p:cNvPicPr>
+          <p:nvPr/>
+        </p:nvPicPr>
+        <p:blipFill>
+          <a:blip r:embed="rId3"/>
+          <a:stretch>
+            <a:fillRect/>
+          </a:stretch>
+        </p:blipFill>
+        <p:spPr>
+          <a:xfrm>
+            <a:off x="-1" y="5118628"/>
+            <a:ext cx="12192000" cy="1727265"/>
+          </a:xfrm>
+          <a:prstGeom prst="rect">
+            <a:avLst/>
+          </a:prstGeom>
+        </p:spPr>
+      </p:pic>
+      <p:sp>
+        <p:nvSpPr>
+          <p:cNvPr id="7" name="Arrow: Down 6">
+            <a:extLst>
+              <a:ext uri="{FF2B5EF4-FFF2-40B4-BE49-F238E27FC236}">
+                <a16:creationId xmlns:a16="http://schemas.microsoft.com/office/drawing/2014/main" id="{657A7830-C6F5-B0B7-8C38-74F1474A998F}"/>
+              </a:ext>
+            </a:extLst>
+          </p:cNvPr>
+          <p:cNvSpPr/>
+          <p:nvPr/>
+        </p:nvSpPr>
+        <p:spPr>
+          <a:xfrm>
+            <a:off x="5837380" y="4502116"/>
+            <a:ext cx="517237" cy="424873"/>
+          </a:xfrm>
+          <a:prstGeom prst="downArrow">
+            <a:avLst/>
+          </a:prstGeom>
+        </p:spPr>
+        <p:style>
+          <a:lnRef idx="2">
+            <a:schemeClr val="dk1">
+              <a:shade val="15000"/>
+            </a:schemeClr>
+          </a:lnRef>
+          <a:fillRef idx="1">
+            <a:schemeClr val="dk1"/>
+          </a:fillRef>
+          <a:effectRef idx="0">
+            <a:schemeClr val="dk1"/>
+          </a:effectRef>
+          <a:fontRef idx="minor">
+            <a:schemeClr val="lt1"/>
+          </a:fontRef>
+        </p:style>
+        <p:txBody>
+          <a:bodyPr rtlCol="0" anchor="ctr"/>
+          <a:lstStyle/>
+          <a:p>
+            <a:pPr algn="ctr"/>
+            <a:endParaRPr lang="en-US"/>
           </a:p>
         </p:txBody>
       </p:sp>
@@ -3491,7 +4412,7 @@
         <p:cNvPr id="1" name="">
           <a:extLst>
             <a:ext uri="{FF2B5EF4-FFF2-40B4-BE49-F238E27FC236}">
-              <a16:creationId xmlns:a16="http://schemas.microsoft.com/office/drawing/2014/main" id="{ECE25D7D-A080-F22B-7E8D-36EC827289A1}"/>
+              <a16:creationId xmlns:a16="http://schemas.microsoft.com/office/drawing/2014/main" id="{A6949789-428B-712D-0E16-E7BEE926043E}"/>
             </a:ext>
           </a:extLst>
         </p:cNvPr>
@@ -3511,7 +4432,1535 @@
           <p:cNvPr id="3" name="TextBox 2">
             <a:extLst>
               <a:ext uri="{FF2B5EF4-FFF2-40B4-BE49-F238E27FC236}">
-                <a16:creationId xmlns:a16="http://schemas.microsoft.com/office/drawing/2014/main" id="{E33F16A3-A6E8-401E-847B-09570DC6E4CB}"/>
+                <a16:creationId xmlns:a16="http://schemas.microsoft.com/office/drawing/2014/main" id="{720302A8-29E6-3C0E-2452-E28ADC57761A}"/>
+              </a:ext>
+            </a:extLst>
+          </p:cNvPr>
+          <p:cNvSpPr txBox="1"/>
+          <p:nvPr/>
+        </p:nvSpPr>
+        <p:spPr>
+          <a:xfrm>
+            <a:off x="217714" y="255046"/>
+            <a:ext cx="11756571" cy="5526000"/>
+          </a:xfrm>
+          <a:prstGeom prst="rect">
+            <a:avLst/>
+          </a:prstGeom>
+          <a:noFill/>
+        </p:spPr>
+        <p:txBody>
+          <a:bodyPr wrap="square">
+            <a:spAutoFit/>
+          </a:bodyPr>
+          <a:lstStyle/>
+          <a:p>
+            <a:pPr>
+              <a:lnSpc>
+                <a:spcPct val="150000"/>
+              </a:lnSpc>
+              <a:buNone/>
+            </a:pPr>
+            <a:r>
+              <a:rPr lang="az-Latn-AZ" altLang="en-US" sz="1300" b="1" u="sng">
+                <a:solidFill>
+                  <a:srgbClr val="0070C0"/>
+                </a:solidFill>
+                <a:latin typeface="Arial" panose="020B0604020202020204" pitchFamily="34" charset="0"/>
+              </a:rPr>
+              <a:t>https://datatables.net</a:t>
+            </a:r>
+            <a:r>
+              <a:rPr lang="en-US" altLang="en-US" sz="1300">
+                <a:latin typeface="Arial" panose="020B0604020202020204" pitchFamily="34" charset="0"/>
+              </a:rPr>
+              <a:t> </a:t>
+            </a:r>
+            <a:r>
+              <a:rPr lang="az-Latn-AZ" altLang="en-US" sz="1300">
+                <a:latin typeface="Arial" panose="020B0604020202020204" pitchFamily="34" charset="0"/>
+              </a:rPr>
+              <a:t>- </a:t>
+            </a:r>
+            <a:r>
+              <a:rPr lang="en-US" altLang="en-US" sz="1300">
+                <a:latin typeface="Arial" panose="020B0604020202020204" pitchFamily="34" charset="0"/>
+              </a:rPr>
+              <a:t>kitabxanas</a:t>
+            </a:r>
+            <a:r>
+              <a:rPr lang="az-Latn-AZ" altLang="en-US" sz="1300">
+                <a:latin typeface="Arial" panose="020B0604020202020204" pitchFamily="34" charset="0"/>
+              </a:rPr>
+              <a:t>ının CDN linklərini, layihəmizə əlavə edirik. </a:t>
+            </a:r>
+          </a:p>
+          <a:p>
+            <a:pPr>
+              <a:lnSpc>
+                <a:spcPct val="150000"/>
+              </a:lnSpc>
+              <a:buNone/>
+            </a:pPr>
+            <a:endParaRPr lang="az-Latn-AZ" altLang="en-US" sz="1300">
+              <a:latin typeface="Arial" panose="020B0604020202020204" pitchFamily="34" charset="0"/>
+            </a:endParaRPr>
+          </a:p>
+          <a:p>
+            <a:pPr>
+              <a:lnSpc>
+                <a:spcPct val="150000"/>
+              </a:lnSpc>
+              <a:buNone/>
+            </a:pPr>
+            <a:r>
+              <a:rPr lang="en-US" altLang="en-US" sz="1300" b="1">
+                <a:latin typeface="Arial" panose="020B0604020202020204" pitchFamily="34" charset="0"/>
+              </a:rPr>
+              <a:t>https://cdn.datatables.net/1.13.4</a:t>
+            </a:r>
+            <a:r>
+              <a:rPr lang="az-Latn-AZ" altLang="en-US" sz="1300">
+                <a:latin typeface="Arial" panose="020B0604020202020204" pitchFamily="34" charset="0"/>
+              </a:rPr>
+              <a:t>: 	</a:t>
+            </a:r>
+          </a:p>
+          <a:p>
+            <a:pPr marL="742950" lvl="1" indent="-285750">
+              <a:lnSpc>
+                <a:spcPct val="150000"/>
+              </a:lnSpc>
+              <a:buFont typeface="Wingdings" panose="05000000000000000000" pitchFamily="2" charset="2"/>
+              <a:buChar char="q"/>
+            </a:pPr>
+            <a:r>
+              <a:rPr lang="az-Latn-AZ" altLang="en-US" sz="1300" u="sng">
+                <a:latin typeface="Arial" panose="020B0604020202020204" pitchFamily="34" charset="0"/>
+              </a:rPr>
+              <a:t>https://cdn.datatables.net/1.13.4/css/jquery.dataTables.min.css</a:t>
+            </a:r>
+          </a:p>
+          <a:p>
+            <a:pPr marL="742950" lvl="1" indent="-285750">
+              <a:lnSpc>
+                <a:spcPct val="150000"/>
+              </a:lnSpc>
+              <a:buFont typeface="Wingdings" panose="05000000000000000000" pitchFamily="2" charset="2"/>
+              <a:buChar char="q"/>
+            </a:pPr>
+            <a:r>
+              <a:rPr lang="az-Latn-AZ" altLang="en-US" sz="1300" u="sng">
+                <a:latin typeface="Arial" panose="020B0604020202020204" pitchFamily="34" charset="0"/>
+              </a:rPr>
+              <a:t>http://cdn.datatables.net/1.13.4/js/jquery.dataTables.min.js</a:t>
+            </a:r>
+          </a:p>
+          <a:p>
+            <a:pPr>
+              <a:lnSpc>
+                <a:spcPct val="150000"/>
+              </a:lnSpc>
+              <a:buNone/>
+            </a:pPr>
+            <a:endParaRPr lang="az-Latn-AZ" altLang="en-US" sz="1300">
+              <a:latin typeface="Arial" panose="020B0604020202020204" pitchFamily="34" charset="0"/>
+            </a:endParaRPr>
+          </a:p>
+          <a:p>
+            <a:pPr>
+              <a:lnSpc>
+                <a:spcPct val="150000"/>
+              </a:lnSpc>
+              <a:buNone/>
+            </a:pPr>
+            <a:endParaRPr lang="az-Latn-AZ" altLang="en-US" sz="1300">
+              <a:latin typeface="Arial" panose="020B0604020202020204" pitchFamily="34" charset="0"/>
+            </a:endParaRPr>
+          </a:p>
+          <a:p>
+            <a:pPr>
+              <a:lnSpc>
+                <a:spcPct val="150000"/>
+              </a:lnSpc>
+              <a:buNone/>
+            </a:pPr>
+            <a:r>
+              <a:rPr lang="fr-FR" altLang="en-US" sz="1600" b="1">
+                <a:solidFill>
+                  <a:srgbClr val="FF0000"/>
+                </a:solidFill>
+                <a:latin typeface="Arial" panose="020B0604020202020204" pitchFamily="34" charset="0"/>
+              </a:rPr>
+              <a:t>datatables.net (https://datatables.net) — Frontend JS Plugin</a:t>
+            </a:r>
+            <a:r>
+              <a:rPr lang="az-Latn-AZ" altLang="en-US" sz="1300">
+                <a:latin typeface="Arial" panose="020B0604020202020204" pitchFamily="34" charset="0"/>
+              </a:rPr>
+              <a:t>:</a:t>
+            </a:r>
+          </a:p>
+          <a:p>
+            <a:pPr marL="742950" lvl="1" indent="-285750">
+              <a:lnSpc>
+                <a:spcPct val="150000"/>
+              </a:lnSpc>
+              <a:buFont typeface="Wingdings" panose="05000000000000000000" pitchFamily="2" charset="2"/>
+              <a:buChar char="q"/>
+            </a:pPr>
+            <a:r>
+              <a:rPr lang="az-Latn-AZ" altLang="en-US" sz="1300">
+                <a:latin typeface="Arial" panose="020B0604020202020204" pitchFamily="34" charset="0"/>
+              </a:rPr>
+              <a:t>Bu kitabxana, jQuery ilə işləyən bir JavaScript kitabxanasıdır:</a:t>
+            </a:r>
+          </a:p>
+          <a:p>
+            <a:pPr marL="1200150" lvl="2" indent="-285750">
+              <a:lnSpc>
+                <a:spcPct val="150000"/>
+              </a:lnSpc>
+              <a:buFont typeface="Wingdings" panose="05000000000000000000" pitchFamily="2" charset="2"/>
+              <a:buChar char="§"/>
+            </a:pPr>
+            <a:r>
+              <a:rPr lang="az-Latn-AZ" altLang="en-US" sz="1300">
+                <a:latin typeface="Arial" panose="020B0604020202020204" pitchFamily="34" charset="0"/>
+              </a:rPr>
+              <a:t>Cədvəldəki data-nı süzmək, sıralamaq, səhifələmək üçün istifadə edilir.</a:t>
+            </a:r>
+          </a:p>
+          <a:p>
+            <a:pPr marL="1200150" lvl="2" indent="-285750">
+              <a:lnSpc>
+                <a:spcPct val="150000"/>
+              </a:lnSpc>
+              <a:buFont typeface="Wingdings" panose="05000000000000000000" pitchFamily="2" charset="2"/>
+              <a:buChar char="§"/>
+            </a:pPr>
+            <a:r>
+              <a:rPr lang="az-Latn-AZ" altLang="en-US" sz="1300">
+                <a:latin typeface="Arial" panose="020B0604020202020204" pitchFamily="34" charset="0"/>
+              </a:rPr>
+              <a:t>Klient tərəfində və ya server tərəfində işləyə bilər.</a:t>
+            </a:r>
+          </a:p>
+          <a:p>
+            <a:pPr marL="1200150" lvl="2" indent="-285750">
+              <a:lnSpc>
+                <a:spcPct val="150000"/>
+              </a:lnSpc>
+              <a:buFont typeface="Wingdings" panose="05000000000000000000" pitchFamily="2" charset="2"/>
+              <a:buChar char="§"/>
+            </a:pPr>
+            <a:r>
+              <a:rPr lang="az-Latn-AZ" altLang="en-US" sz="1300">
+                <a:latin typeface="Arial" panose="020B0604020202020204" pitchFamily="34" charset="0"/>
+              </a:rPr>
+              <a:t>HTML table üzərində işləyir</a:t>
+            </a:r>
+          </a:p>
+          <a:p>
+            <a:pPr>
+              <a:lnSpc>
+                <a:spcPct val="150000"/>
+              </a:lnSpc>
+              <a:buNone/>
+            </a:pPr>
+            <a:endParaRPr lang="az-Latn-AZ" altLang="en-US" sz="1300">
+              <a:latin typeface="Arial" panose="020B0604020202020204" pitchFamily="34" charset="0"/>
+            </a:endParaRPr>
+          </a:p>
+          <a:p>
+            <a:pPr>
+              <a:lnSpc>
+                <a:spcPct val="150000"/>
+              </a:lnSpc>
+              <a:buNone/>
+            </a:pPr>
+            <a:endParaRPr lang="az-Latn-AZ" altLang="en-US" sz="1300">
+              <a:latin typeface="Arial" panose="020B0604020202020204" pitchFamily="34" charset="0"/>
+            </a:endParaRPr>
+          </a:p>
+          <a:p>
+            <a:pPr>
+              <a:lnSpc>
+                <a:spcPct val="150000"/>
+              </a:lnSpc>
+              <a:buNone/>
+            </a:pPr>
+            <a:r>
+              <a:rPr lang="az-Latn-AZ" altLang="en-US" sz="1300">
+                <a:latin typeface="Arial" panose="020B0604020202020204" pitchFamily="34" charset="0"/>
+              </a:rPr>
+              <a:t>Bu plugin -ni istifadə edə bilmək üçün, Datatable linklərini </a:t>
+            </a:r>
+            <a:r>
+              <a:rPr lang="az-Latn-AZ" altLang="en-US" sz="1300" b="1">
+                <a:solidFill>
+                  <a:srgbClr val="00B050"/>
+                </a:solidFill>
+                <a:latin typeface="Arial" panose="020B0604020202020204" pitchFamily="34" charset="0"/>
+              </a:rPr>
+              <a:t>link</a:t>
+            </a:r>
+            <a:r>
+              <a:rPr lang="az-Latn-AZ" altLang="en-US" sz="1300">
+                <a:latin typeface="Arial" panose="020B0604020202020204" pitchFamily="34" charset="0"/>
+              </a:rPr>
+              <a:t> və </a:t>
+            </a:r>
+            <a:r>
+              <a:rPr lang="az-Latn-AZ" altLang="en-US" sz="1300" b="1">
+                <a:solidFill>
+                  <a:srgbClr val="00B050"/>
+                </a:solidFill>
+                <a:latin typeface="Arial" panose="020B0604020202020204" pitchFamily="34" charset="0"/>
+              </a:rPr>
+              <a:t>script</a:t>
+            </a:r>
+            <a:r>
+              <a:rPr lang="az-Latn-AZ" altLang="en-US" sz="1300">
+                <a:latin typeface="Arial" panose="020B0604020202020204" pitchFamily="34" charset="0"/>
+              </a:rPr>
+              <a:t> elementləri </a:t>
+            </a:r>
+          </a:p>
+          <a:p>
+            <a:pPr>
+              <a:lnSpc>
+                <a:spcPct val="150000"/>
+              </a:lnSpc>
+              <a:buNone/>
+            </a:pPr>
+            <a:r>
+              <a:rPr lang="az-Latn-AZ" altLang="en-US" sz="1300">
+                <a:latin typeface="Arial" panose="020B0604020202020204" pitchFamily="34" charset="0"/>
+              </a:rPr>
+              <a:t>ilə `</a:t>
+            </a:r>
+            <a:r>
+              <a:rPr lang="en-US" altLang="en-US" sz="1300" b="1">
+                <a:latin typeface="Arial" panose="020B0604020202020204" pitchFamily="34" charset="0"/>
+              </a:rPr>
+              <a:t>resources\views\admin\layouts\</a:t>
+            </a:r>
+            <a:r>
+              <a:rPr lang="en-US" altLang="en-US" sz="1300" b="1" u="sng">
+                <a:latin typeface="Arial" panose="020B0604020202020204" pitchFamily="34" charset="0"/>
+              </a:rPr>
+              <a:t>master.blade.php</a:t>
+            </a:r>
+            <a:r>
+              <a:rPr lang="az-Latn-AZ" altLang="en-US" sz="1300">
+                <a:latin typeface="Arial" panose="020B0604020202020204" pitchFamily="34" charset="0"/>
+              </a:rPr>
+              <a:t>` faylına qoşuruq.</a:t>
+            </a:r>
+          </a:p>
+          <a:p>
+            <a:pPr>
+              <a:lnSpc>
+                <a:spcPct val="150000"/>
+              </a:lnSpc>
+              <a:buNone/>
+            </a:pPr>
+            <a:endParaRPr lang="az-Latn-AZ" altLang="en-US" sz="1300">
+              <a:latin typeface="Arial" panose="020B0604020202020204" pitchFamily="34" charset="0"/>
+            </a:endParaRPr>
+          </a:p>
+          <a:p>
+            <a:pPr>
+              <a:lnSpc>
+                <a:spcPct val="150000"/>
+              </a:lnSpc>
+              <a:buNone/>
+            </a:pPr>
+            <a:endParaRPr lang="az-Latn-AZ" altLang="en-US" sz="1300">
+              <a:latin typeface="Arial" panose="020B0604020202020204" pitchFamily="34" charset="0"/>
+            </a:endParaRPr>
+          </a:p>
+        </p:txBody>
+      </p:sp>
+      <p:pic>
+        <p:nvPicPr>
+          <p:cNvPr id="4" name="Picture 3">
+            <a:extLst>
+              <a:ext uri="{FF2B5EF4-FFF2-40B4-BE49-F238E27FC236}">
+                <a16:creationId xmlns:a16="http://schemas.microsoft.com/office/drawing/2014/main" id="{26CF2253-0771-2291-7838-562919223BD5}"/>
+              </a:ext>
+            </a:extLst>
+          </p:cNvPr>
+          <p:cNvPicPr>
+            <a:picLocks noChangeAspect="1"/>
+          </p:cNvPicPr>
+          <p:nvPr/>
+        </p:nvPicPr>
+        <p:blipFill>
+          <a:blip r:embed="rId2"/>
+          <a:stretch>
+            <a:fillRect/>
+          </a:stretch>
+        </p:blipFill>
+        <p:spPr>
+          <a:xfrm>
+            <a:off x="7176655" y="2862454"/>
+            <a:ext cx="5015345" cy="3995545"/>
+          </a:xfrm>
+          <a:prstGeom prst="rect">
+            <a:avLst/>
+          </a:prstGeom>
+        </p:spPr>
+      </p:pic>
+    </p:spTree>
+    <p:extLst>
+      <p:ext uri="{BB962C8B-B14F-4D97-AF65-F5344CB8AC3E}">
+        <p14:creationId xmlns:p14="http://schemas.microsoft.com/office/powerpoint/2010/main" val="3323326282"/>
+      </p:ext>
+    </p:extLst>
+  </p:cSld>
+  <p:clrMapOvr>
+    <a:masterClrMapping/>
+  </p:clrMapOvr>
+</p:sld>
+</file>
+
+<file path=ppt/slides/slide4.xml><?xml version="1.0" encoding="utf-8"?>
+<p:sld xmlns:a="http://schemas.openxmlformats.org/drawingml/2006/main" xmlns:r="http://schemas.openxmlformats.org/officeDocument/2006/relationships" xmlns:p="http://schemas.openxmlformats.org/presentationml/2006/main">
+  <p:cSld>
+    <p:spTree>
+      <p:nvGrpSpPr>
+        <p:cNvPr id="1" name="">
+          <a:extLst>
+            <a:ext uri="{FF2B5EF4-FFF2-40B4-BE49-F238E27FC236}">
+              <a16:creationId xmlns:a16="http://schemas.microsoft.com/office/drawing/2014/main" id="{2AE8B78E-8BCE-1E86-2313-A7FD72691393}"/>
+            </a:ext>
+          </a:extLst>
+        </p:cNvPr>
+        <p:cNvGrpSpPr/>
+        <p:nvPr/>
+      </p:nvGrpSpPr>
+      <p:grpSpPr>
+        <a:xfrm>
+          <a:off x="0" y="0"/>
+          <a:ext cx="0" cy="0"/>
+          <a:chOff x="0" y="0"/>
+          <a:chExt cx="0" cy="0"/>
+        </a:xfrm>
+      </p:grpSpPr>
+      <p:sp>
+        <p:nvSpPr>
+          <p:cNvPr id="3" name="TextBox 2">
+            <a:extLst>
+              <a:ext uri="{FF2B5EF4-FFF2-40B4-BE49-F238E27FC236}">
+                <a16:creationId xmlns:a16="http://schemas.microsoft.com/office/drawing/2014/main" id="{B5172B35-BD19-FE68-066C-89691CB07D8F}"/>
+              </a:ext>
+            </a:extLst>
+          </p:cNvPr>
+          <p:cNvSpPr txBox="1"/>
+          <p:nvPr/>
+        </p:nvSpPr>
+        <p:spPr>
+          <a:xfrm>
+            <a:off x="217714" y="162682"/>
+            <a:ext cx="11756571" cy="2555956"/>
+          </a:xfrm>
+          <a:prstGeom prst="rect">
+            <a:avLst/>
+          </a:prstGeom>
+          <a:noFill/>
+        </p:spPr>
+        <p:txBody>
+          <a:bodyPr wrap="square">
+            <a:spAutoFit/>
+          </a:bodyPr>
+          <a:lstStyle/>
+          <a:p>
+            <a:pPr>
+              <a:lnSpc>
+                <a:spcPct val="150000"/>
+              </a:lnSpc>
+              <a:buNone/>
+            </a:pPr>
+            <a:r>
+              <a:rPr lang="az-Latn-AZ" altLang="en-US" sz="1300">
+                <a:latin typeface="Arial" panose="020B0604020202020204" pitchFamily="34" charset="0"/>
+              </a:rPr>
+              <a:t>İndi ilk öncə `</a:t>
+            </a:r>
+            <a:r>
+              <a:rPr lang="az-Latn-AZ" altLang="en-US" sz="1300" b="1">
+                <a:latin typeface="Arial" panose="020B0604020202020204" pitchFamily="34" charset="0"/>
+              </a:rPr>
+              <a:t>Yajrabox</a:t>
+            </a:r>
+            <a:r>
+              <a:rPr lang="az-Latn-AZ" altLang="en-US" sz="1300">
+                <a:latin typeface="Arial" panose="020B0604020202020204" pitchFamily="34" charset="0"/>
+              </a:rPr>
+              <a:t>` ilə `</a:t>
+            </a:r>
+            <a:r>
+              <a:rPr lang="az-Latn-AZ" altLang="en-US" sz="1300" b="1">
+                <a:latin typeface="Arial" panose="020B0604020202020204" pitchFamily="34" charset="0"/>
+              </a:rPr>
+              <a:t>datatables</a:t>
+            </a:r>
+            <a:r>
+              <a:rPr lang="az-Latn-AZ" altLang="en-US" sz="1300">
+                <a:latin typeface="Arial" panose="020B0604020202020204" pitchFamily="34" charset="0"/>
+              </a:rPr>
+              <a:t>` arasında olan əlaqəni izah edək:</a:t>
+            </a:r>
+            <a:endParaRPr kumimoji="0" lang="az-Latn-AZ" altLang="en-US" sz="1300" b="0" i="0" u="none" strike="noStrike" cap="none" normalizeH="0" baseline="0">
+              <a:ln>
+                <a:noFill/>
+              </a:ln>
+              <a:solidFill>
+                <a:schemeClr val="tx1"/>
+              </a:solidFill>
+              <a:effectLst/>
+              <a:latin typeface="Arial" panose="020B0604020202020204" pitchFamily="34" charset="0"/>
+            </a:endParaRPr>
+          </a:p>
+          <a:p>
+            <a:pPr marL="742950" lvl="1" indent="-285750">
+              <a:lnSpc>
+                <a:spcPct val="250000"/>
+              </a:lnSpc>
+              <a:buFont typeface="Wingdings" panose="05000000000000000000" pitchFamily="2" charset="2"/>
+              <a:buChar char="q"/>
+            </a:pPr>
+            <a:r>
+              <a:rPr lang="en-US" altLang="en-US" sz="1300" b="1">
+                <a:latin typeface="Arial" panose="020B0604020202020204" pitchFamily="34" charset="0"/>
+              </a:rPr>
+              <a:t>Yajra paketi</a:t>
+            </a:r>
+            <a:r>
+              <a:rPr lang="az-Latn-AZ" altLang="en-US" sz="1300">
+                <a:latin typeface="Arial" panose="020B0604020202020204" pitchFamily="34" charset="0"/>
+              </a:rPr>
+              <a:t>,</a:t>
+            </a:r>
+            <a:r>
+              <a:rPr lang="en-US" altLang="en-US" sz="1300">
+                <a:latin typeface="Arial" panose="020B0604020202020204" pitchFamily="34" charset="0"/>
+              </a:rPr>
+              <a:t> </a:t>
+            </a:r>
+            <a:r>
+              <a:rPr lang="az-Latn-AZ" altLang="en-US" sz="1300">
+                <a:latin typeface="Arial" panose="020B0604020202020204" pitchFamily="34" charset="0"/>
+              </a:rPr>
+              <a:t>verilənlər bazasından dataları çəkərək </a:t>
+            </a:r>
+            <a:r>
+              <a:rPr lang="az-Latn-AZ" altLang="en-US" sz="1300" b="1">
+                <a:latin typeface="Arial" panose="020B0604020202020204" pitchFamily="34" charset="0"/>
+              </a:rPr>
+              <a:t>`</a:t>
+            </a:r>
+            <a:r>
+              <a:rPr lang="en-US" altLang="en-US" sz="1300" b="1">
+                <a:latin typeface="Arial" panose="020B0604020202020204" pitchFamily="34" charset="0"/>
+              </a:rPr>
+              <a:t>resources\views\admin\slider\</a:t>
+            </a:r>
+            <a:r>
+              <a:rPr lang="en-US" altLang="en-US" sz="1300" b="1" u="sng">
+                <a:latin typeface="Arial" panose="020B0604020202020204" pitchFamily="34" charset="0"/>
+              </a:rPr>
+              <a:t>index.blade.php</a:t>
+            </a:r>
+            <a:r>
+              <a:rPr lang="az-Latn-AZ" altLang="en-US" sz="1300" b="1">
+                <a:latin typeface="Arial" panose="020B0604020202020204" pitchFamily="34" charset="0"/>
+              </a:rPr>
+              <a:t>` </a:t>
+            </a:r>
+            <a:r>
+              <a:rPr lang="az-Latn-AZ" altLang="en-US" sz="1300">
+                <a:latin typeface="Arial" panose="020B0604020202020204" pitchFamily="34" charset="0"/>
+              </a:rPr>
+              <a:t>faylında əks etdirəcək. </a:t>
+            </a:r>
+          </a:p>
+          <a:p>
+            <a:pPr marL="742950" lvl="1" indent="-285750">
+              <a:lnSpc>
+                <a:spcPct val="250000"/>
+              </a:lnSpc>
+              <a:buFont typeface="Wingdings" panose="05000000000000000000" pitchFamily="2" charset="2"/>
+              <a:buChar char="q"/>
+            </a:pPr>
+            <a:r>
+              <a:rPr lang="az-Latn-AZ" altLang="en-US" sz="1300">
+                <a:latin typeface="Arial" panose="020B0604020202020204" pitchFamily="34" charset="0"/>
+              </a:rPr>
+              <a:t>`</a:t>
+            </a:r>
+            <a:r>
+              <a:rPr lang="az-Latn-AZ" altLang="en-US" sz="1300" b="1">
+                <a:latin typeface="Arial" panose="020B0604020202020204" pitchFamily="34" charset="0"/>
+              </a:rPr>
+              <a:t>datatables</a:t>
+            </a:r>
+            <a:r>
+              <a:rPr lang="az-Latn-AZ" altLang="en-US" sz="1300">
+                <a:latin typeface="Arial" panose="020B0604020202020204" pitchFamily="34" charset="0"/>
+              </a:rPr>
+              <a:t>` kitabxanası isə, </a:t>
+            </a:r>
+            <a:r>
+              <a:rPr lang="az-Latn-AZ" altLang="en-US" sz="1300" b="1">
+                <a:latin typeface="Arial" panose="020B0604020202020204" pitchFamily="34" charset="0"/>
+              </a:rPr>
+              <a:t>yajra paketi </a:t>
+            </a:r>
+            <a:r>
+              <a:rPr lang="az-Latn-AZ" altLang="en-US" sz="1300">
+                <a:latin typeface="Arial" panose="020B0604020202020204" pitchFamily="34" charset="0"/>
+              </a:rPr>
+              <a:t>ilə əlavə edilən </a:t>
+            </a:r>
+            <a:r>
+              <a:rPr lang="az-Latn-AZ" altLang="en-US" sz="1300" b="1">
+                <a:latin typeface="Arial" panose="020B0604020202020204" pitchFamily="34" charset="0"/>
+              </a:rPr>
+              <a:t>dataların</a:t>
+            </a:r>
+            <a:r>
+              <a:rPr lang="az-Latn-AZ" altLang="en-US" sz="1300">
+                <a:latin typeface="Arial" panose="020B0604020202020204" pitchFamily="34" charset="0"/>
+              </a:rPr>
+              <a:t> görüntüsünə, səliqəli </a:t>
+            </a:r>
+            <a:r>
+              <a:rPr lang="az-Latn-AZ" altLang="en-US" sz="1300" b="1">
+                <a:latin typeface="Arial" panose="020B0604020202020204" pitchFamily="34" charset="0"/>
+              </a:rPr>
+              <a:t>stil</a:t>
+            </a:r>
+            <a:r>
+              <a:rPr lang="az-Latn-AZ" altLang="en-US" sz="1300">
+                <a:latin typeface="Arial" panose="020B0604020202020204" pitchFamily="34" charset="0"/>
+              </a:rPr>
+              <a:t> vermək üçündür.</a:t>
+            </a:r>
+          </a:p>
+          <a:p>
+            <a:pPr>
+              <a:lnSpc>
+                <a:spcPct val="150000"/>
+              </a:lnSpc>
+              <a:buNone/>
+            </a:pPr>
+            <a:endParaRPr kumimoji="0" lang="az-Latn-AZ" altLang="en-US" sz="1300" i="0" u="none" strike="noStrike" cap="none" normalizeH="0" baseline="0">
+              <a:ln>
+                <a:noFill/>
+              </a:ln>
+              <a:solidFill>
+                <a:schemeClr val="tx1"/>
+              </a:solidFill>
+              <a:effectLst/>
+              <a:latin typeface="Arial" panose="020B0604020202020204" pitchFamily="34" charset="0"/>
+            </a:endParaRPr>
+          </a:p>
+          <a:p>
+            <a:pPr>
+              <a:lnSpc>
+                <a:spcPct val="150000"/>
+              </a:lnSpc>
+              <a:buNone/>
+            </a:pPr>
+            <a:endParaRPr lang="az-Latn-AZ" altLang="en-US" sz="1300">
+              <a:latin typeface="Arial" panose="020B0604020202020204" pitchFamily="34" charset="0"/>
+            </a:endParaRPr>
+          </a:p>
+          <a:p>
+            <a:pPr>
+              <a:lnSpc>
+                <a:spcPct val="150000"/>
+              </a:lnSpc>
+              <a:buNone/>
+            </a:pPr>
+            <a:endParaRPr kumimoji="0" lang="az-Latn-AZ" altLang="en-US" sz="1300" i="0" u="none" strike="noStrike" cap="none" normalizeH="0" baseline="0">
+              <a:ln>
+                <a:noFill/>
+              </a:ln>
+              <a:solidFill>
+                <a:schemeClr val="tx1"/>
+              </a:solidFill>
+              <a:effectLst/>
+              <a:latin typeface="Arial" panose="020B0604020202020204" pitchFamily="34" charset="0"/>
+            </a:endParaRPr>
+          </a:p>
+          <a:p>
+            <a:pPr>
+              <a:lnSpc>
+                <a:spcPct val="150000"/>
+              </a:lnSpc>
+              <a:buNone/>
+            </a:pPr>
+            <a:endParaRPr kumimoji="0" lang="en-US" altLang="en-US" sz="1300" i="0" u="none" strike="noStrike" cap="none" normalizeH="0" baseline="0">
+              <a:ln>
+                <a:noFill/>
+              </a:ln>
+              <a:solidFill>
+                <a:schemeClr val="tx1"/>
+              </a:solidFill>
+              <a:effectLst/>
+              <a:latin typeface="Arial" panose="020B0604020202020204" pitchFamily="34" charset="0"/>
+            </a:endParaRPr>
+          </a:p>
+        </p:txBody>
+      </p:sp>
+    </p:spTree>
+    <p:extLst>
+      <p:ext uri="{BB962C8B-B14F-4D97-AF65-F5344CB8AC3E}">
+        <p14:creationId xmlns:p14="http://schemas.microsoft.com/office/powerpoint/2010/main" val="326788071"/>
+      </p:ext>
+    </p:extLst>
+  </p:cSld>
+  <p:clrMapOvr>
+    <a:masterClrMapping/>
+  </p:clrMapOvr>
+</p:sld>
+</file>
+
+<file path=ppt/slides/slide5.xml><?xml version="1.0" encoding="utf-8"?>
+<p:sld xmlns:a="http://schemas.openxmlformats.org/drawingml/2006/main" xmlns:r="http://schemas.openxmlformats.org/officeDocument/2006/relationships" xmlns:p="http://schemas.openxmlformats.org/presentationml/2006/main">
+  <p:cSld>
+    <p:spTree>
+      <p:nvGrpSpPr>
+        <p:cNvPr id="1" name="">
+          <a:extLst>
+            <a:ext uri="{FF2B5EF4-FFF2-40B4-BE49-F238E27FC236}">
+              <a16:creationId xmlns:a16="http://schemas.microsoft.com/office/drawing/2014/main" id="{28756ED9-1D9C-273A-7DEE-434149F87D1B}"/>
+            </a:ext>
+          </a:extLst>
+        </p:cNvPr>
+        <p:cNvGrpSpPr/>
+        <p:nvPr/>
+      </p:nvGrpSpPr>
+      <p:grpSpPr>
+        <a:xfrm>
+          <a:off x="0" y="0"/>
+          <a:ext cx="0" cy="0"/>
+          <a:chOff x="0" y="0"/>
+          <a:chExt cx="0" cy="0"/>
+        </a:xfrm>
+      </p:grpSpPr>
+      <p:sp>
+        <p:nvSpPr>
+          <p:cNvPr id="3" name="TextBox 2">
+            <a:extLst>
+              <a:ext uri="{FF2B5EF4-FFF2-40B4-BE49-F238E27FC236}">
+                <a16:creationId xmlns:a16="http://schemas.microsoft.com/office/drawing/2014/main" id="{1055F19E-4EE4-F7C9-A44B-859ED924E0A5}"/>
+              </a:ext>
+            </a:extLst>
+          </p:cNvPr>
+          <p:cNvSpPr txBox="1"/>
+          <p:nvPr/>
+        </p:nvSpPr>
+        <p:spPr>
+          <a:xfrm>
+            <a:off x="217715" y="255046"/>
+            <a:ext cx="7291450" cy="1255600"/>
+          </a:xfrm>
+          <a:prstGeom prst="rect">
+            <a:avLst/>
+          </a:prstGeom>
+          <a:noFill/>
+        </p:spPr>
+        <p:txBody>
+          <a:bodyPr wrap="square">
+            <a:spAutoFit/>
+          </a:bodyPr>
+          <a:lstStyle/>
+          <a:p>
+            <a:pPr>
+              <a:lnSpc>
+                <a:spcPct val="150000"/>
+              </a:lnSpc>
+              <a:buNone/>
+            </a:pPr>
+            <a:r>
+              <a:rPr lang="az-Latn-AZ" altLang="en-US" sz="1300">
+                <a:latin typeface="Arial" panose="020B0604020202020204" pitchFamily="34" charset="0"/>
+              </a:rPr>
+              <a:t>İndi</a:t>
+            </a:r>
+            <a:r>
+              <a:rPr lang="en-US" altLang="en-US" sz="1300">
+                <a:latin typeface="Arial" panose="020B0604020202020204" pitchFamily="34" charset="0"/>
+              </a:rPr>
+              <a:t> isə, şəkildə göstərilən əmr ilə, </a:t>
+            </a:r>
+            <a:r>
+              <a:rPr lang="az-Latn-AZ" altLang="en-US" sz="1300" b="1">
+                <a:latin typeface="Arial" panose="020B0604020202020204" pitchFamily="34" charset="0"/>
+              </a:rPr>
+              <a:t>Slider</a:t>
+            </a:r>
+            <a:r>
+              <a:rPr lang="en-US" altLang="en-US" sz="1300" b="1">
+                <a:latin typeface="Arial" panose="020B0604020202020204" pitchFamily="34" charset="0"/>
+              </a:rPr>
+              <a:t>DataTable</a:t>
+            </a:r>
+            <a:r>
+              <a:rPr lang="en-US" altLang="en-US" sz="1300">
+                <a:latin typeface="Arial" panose="020B0604020202020204" pitchFamily="34" charset="0"/>
+              </a:rPr>
+              <a:t> adlı </a:t>
+            </a:r>
+            <a:r>
+              <a:rPr lang="en-US" altLang="en-US" sz="1300" b="1">
+                <a:latin typeface="Arial" panose="020B0604020202020204" pitchFamily="34" charset="0"/>
+              </a:rPr>
+              <a:t>class</a:t>
+            </a:r>
+            <a:r>
+              <a:rPr lang="en-US" altLang="en-US" sz="1300">
+                <a:latin typeface="Arial" panose="020B0604020202020204" pitchFamily="34" charset="0"/>
+              </a:rPr>
+              <a:t> yaradaraq </a:t>
+            </a:r>
+            <a:r>
+              <a:rPr lang="az-Latn-AZ" altLang="en-US" sz="1300">
+                <a:latin typeface="Arial" panose="020B0604020202020204" pitchFamily="34" charset="0"/>
+              </a:rPr>
+              <a:t>onu </a:t>
+            </a:r>
+            <a:r>
+              <a:rPr lang="en-US" altLang="en-US" sz="1300">
+                <a:latin typeface="Arial" panose="020B0604020202020204" pitchFamily="34" charset="0"/>
+              </a:rPr>
+              <a:t>konfiqurasiya edəcəyik.</a:t>
+            </a:r>
+            <a:endParaRPr lang="az-Latn-AZ" altLang="en-US" sz="1300">
+              <a:latin typeface="Arial" panose="020B0604020202020204" pitchFamily="34" charset="0"/>
+            </a:endParaRPr>
+          </a:p>
+          <a:p>
+            <a:pPr>
+              <a:lnSpc>
+                <a:spcPct val="150000"/>
+              </a:lnSpc>
+              <a:buNone/>
+            </a:pPr>
+            <a:endParaRPr kumimoji="0" lang="az-Latn-AZ" altLang="en-US" sz="1300" b="0" i="0" u="none" strike="noStrike" cap="none" normalizeH="0" baseline="0">
+              <a:ln>
+                <a:noFill/>
+              </a:ln>
+              <a:solidFill>
+                <a:schemeClr val="tx1"/>
+              </a:solidFill>
+              <a:effectLst/>
+              <a:latin typeface="Arial" panose="020B0604020202020204" pitchFamily="34" charset="0"/>
+            </a:endParaRPr>
+          </a:p>
+          <a:p>
+            <a:pPr>
+              <a:lnSpc>
+                <a:spcPct val="150000"/>
+              </a:lnSpc>
+              <a:buNone/>
+            </a:pPr>
+            <a:r>
+              <a:rPr kumimoji="0" lang="az-Latn-AZ" altLang="en-US" sz="1300" i="0" u="none" strike="noStrike" cap="none" normalizeH="0" baseline="0">
+                <a:ln>
+                  <a:noFill/>
+                </a:ln>
+                <a:solidFill>
+                  <a:schemeClr val="tx1"/>
+                </a:solidFill>
+                <a:effectLst/>
+                <a:latin typeface="Arial" panose="020B0604020202020204" pitchFamily="34" charset="0"/>
+              </a:rPr>
+              <a:t>Bu faylın içində nəsə dəyişməyə ehtiyac yoxdur</a:t>
+            </a:r>
+            <a:r>
+              <a:rPr kumimoji="0" lang="az-Latn-AZ" altLang="en-US" sz="1300" b="1" i="0" u="none" strike="noStrike" cap="none" normalizeH="0" baseline="0">
+                <a:ln>
+                  <a:noFill/>
+                </a:ln>
+                <a:solidFill>
+                  <a:schemeClr val="tx1"/>
+                </a:solidFill>
+                <a:effectLst/>
+                <a:latin typeface="Arial" panose="020B0604020202020204" pitchFamily="34" charset="0"/>
+              </a:rPr>
+              <a:t>.</a:t>
+            </a:r>
+            <a:endParaRPr kumimoji="0" lang="en-US" altLang="en-US" sz="1300" b="1" i="0" u="none" strike="noStrike" cap="none" normalizeH="0" baseline="0">
+              <a:ln>
+                <a:noFill/>
+              </a:ln>
+              <a:solidFill>
+                <a:schemeClr val="tx1"/>
+              </a:solidFill>
+              <a:effectLst/>
+              <a:latin typeface="Arial" panose="020B0604020202020204" pitchFamily="34" charset="0"/>
+            </a:endParaRPr>
+          </a:p>
+        </p:txBody>
+      </p:sp>
+      <p:pic>
+        <p:nvPicPr>
+          <p:cNvPr id="4" name="Picture 3">
+            <a:extLst>
+              <a:ext uri="{FF2B5EF4-FFF2-40B4-BE49-F238E27FC236}">
+                <a16:creationId xmlns:a16="http://schemas.microsoft.com/office/drawing/2014/main" id="{1D66E4C3-DAAB-21D6-7F91-767D4A93CF82}"/>
+              </a:ext>
+            </a:extLst>
+          </p:cNvPr>
+          <p:cNvPicPr>
+            <a:picLocks noChangeAspect="1"/>
+          </p:cNvPicPr>
+          <p:nvPr/>
+        </p:nvPicPr>
+        <p:blipFill>
+          <a:blip r:embed="rId2"/>
+          <a:stretch>
+            <a:fillRect/>
+          </a:stretch>
+        </p:blipFill>
+        <p:spPr>
+          <a:xfrm>
+            <a:off x="7684655" y="0"/>
+            <a:ext cx="4507345" cy="3023332"/>
+          </a:xfrm>
+          <a:prstGeom prst="rect">
+            <a:avLst/>
+          </a:prstGeom>
+        </p:spPr>
+      </p:pic>
+      <p:pic>
+        <p:nvPicPr>
+          <p:cNvPr id="6" name="Picture 5">
+            <a:extLst>
+              <a:ext uri="{FF2B5EF4-FFF2-40B4-BE49-F238E27FC236}">
+                <a16:creationId xmlns:a16="http://schemas.microsoft.com/office/drawing/2014/main" id="{4C0C4137-F53E-A58B-0797-5EFFF0B4AEA1}"/>
+              </a:ext>
+            </a:extLst>
+          </p:cNvPr>
+          <p:cNvPicPr>
+            <a:picLocks noChangeAspect="1"/>
+          </p:cNvPicPr>
+          <p:nvPr/>
+        </p:nvPicPr>
+        <p:blipFill>
+          <a:blip r:embed="rId3"/>
+          <a:stretch>
+            <a:fillRect/>
+          </a:stretch>
+        </p:blipFill>
+        <p:spPr>
+          <a:xfrm>
+            <a:off x="1" y="1727200"/>
+            <a:ext cx="6278169" cy="5130799"/>
+          </a:xfrm>
+          <a:prstGeom prst="rect">
+            <a:avLst/>
+          </a:prstGeom>
+        </p:spPr>
+      </p:pic>
+    </p:spTree>
+    <p:extLst>
+      <p:ext uri="{BB962C8B-B14F-4D97-AF65-F5344CB8AC3E}">
+        <p14:creationId xmlns:p14="http://schemas.microsoft.com/office/powerpoint/2010/main" val="3674562050"/>
+      </p:ext>
+    </p:extLst>
+  </p:cSld>
+  <p:clrMapOvr>
+    <a:masterClrMapping/>
+  </p:clrMapOvr>
+</p:sld>
+</file>
+
+<file path=ppt/slides/slide6.xml><?xml version="1.0" encoding="utf-8"?>
+<p:sld xmlns:a="http://schemas.openxmlformats.org/drawingml/2006/main" xmlns:r="http://schemas.openxmlformats.org/officeDocument/2006/relationships" xmlns:p="http://schemas.openxmlformats.org/presentationml/2006/main">
+  <p:cSld>
+    <p:spTree>
+      <p:nvGrpSpPr>
+        <p:cNvPr id="1" name="">
+          <a:extLst>
+            <a:ext uri="{FF2B5EF4-FFF2-40B4-BE49-F238E27FC236}">
+              <a16:creationId xmlns:a16="http://schemas.microsoft.com/office/drawing/2014/main" id="{0FBE0011-0FFC-A3D7-4F57-F38175E1B8DF}"/>
+            </a:ext>
+          </a:extLst>
+        </p:cNvPr>
+        <p:cNvGrpSpPr/>
+        <p:nvPr/>
+      </p:nvGrpSpPr>
+      <p:grpSpPr>
+        <a:xfrm>
+          <a:off x="0" y="0"/>
+          <a:ext cx="0" cy="0"/>
+          <a:chOff x="0" y="0"/>
+          <a:chExt cx="0" cy="0"/>
+        </a:xfrm>
+      </p:grpSpPr>
+      <p:sp>
+        <p:nvSpPr>
+          <p:cNvPr id="3" name="TextBox 2">
+            <a:extLst>
+              <a:ext uri="{FF2B5EF4-FFF2-40B4-BE49-F238E27FC236}">
+                <a16:creationId xmlns:a16="http://schemas.microsoft.com/office/drawing/2014/main" id="{19CE5B9F-621D-5411-FAF2-27FEAA214B03}"/>
+              </a:ext>
+            </a:extLst>
+          </p:cNvPr>
+          <p:cNvSpPr txBox="1"/>
+          <p:nvPr/>
+        </p:nvSpPr>
+        <p:spPr>
+          <a:xfrm>
+            <a:off x="217713" y="46180"/>
+            <a:ext cx="11756571" cy="568810"/>
+          </a:xfrm>
+          <a:prstGeom prst="rect">
+            <a:avLst/>
+          </a:prstGeom>
+          <a:noFill/>
+        </p:spPr>
+        <p:txBody>
+          <a:bodyPr wrap="square">
+            <a:spAutoFit/>
+          </a:bodyPr>
+          <a:lstStyle/>
+          <a:p>
+            <a:pPr>
+              <a:lnSpc>
+                <a:spcPct val="150000"/>
+              </a:lnSpc>
+              <a:buNone/>
+            </a:pPr>
+            <a:r>
+              <a:rPr lang="az-Latn-AZ" altLang="en-US" sz="1100">
+                <a:latin typeface="Arial" panose="020B0604020202020204" pitchFamily="34" charset="0"/>
+              </a:rPr>
+              <a:t>`</a:t>
+            </a:r>
+            <a:r>
+              <a:rPr lang="az-Latn-AZ" altLang="en-US" sz="1100" b="1">
+                <a:latin typeface="Arial" panose="020B0604020202020204" pitchFamily="34" charset="0"/>
+              </a:rPr>
+              <a:t>app\DataTables\</a:t>
+            </a:r>
+            <a:r>
+              <a:rPr lang="az-Latn-AZ" altLang="en-US" sz="1100" b="1" u="sng">
+                <a:latin typeface="Arial" panose="020B0604020202020204" pitchFamily="34" charset="0"/>
+              </a:rPr>
+              <a:t>SliderDataTable.php</a:t>
+            </a:r>
+            <a:r>
+              <a:rPr lang="az-Latn-AZ" altLang="en-US" sz="1100">
+                <a:latin typeface="Arial" panose="020B0604020202020204" pitchFamily="34" charset="0"/>
+              </a:rPr>
+              <a:t>` adlı </a:t>
+            </a:r>
+            <a:r>
+              <a:rPr lang="az-Latn-AZ" altLang="en-US" sz="1100" b="1">
+                <a:latin typeface="Arial" panose="020B0604020202020204" pitchFamily="34" charset="0"/>
+              </a:rPr>
+              <a:t>class</a:t>
+            </a:r>
+            <a:r>
+              <a:rPr lang="az-Latn-AZ" altLang="en-US" sz="1100">
+                <a:latin typeface="Arial" panose="020B0604020202020204" pitchFamily="34" charset="0"/>
+              </a:rPr>
+              <a:t> -ı istifadə etmək üçün, onu `</a:t>
+            </a:r>
+            <a:r>
+              <a:rPr lang="en-US" altLang="en-US" sz="1100" b="1">
+                <a:latin typeface="Arial" panose="020B0604020202020204" pitchFamily="34" charset="0"/>
+              </a:rPr>
+              <a:t>app\Http\Controllers\Backend\</a:t>
+            </a:r>
+            <a:r>
+              <a:rPr lang="en-US" altLang="en-US" sz="1100" b="1" u="sng">
+                <a:latin typeface="Arial" panose="020B0604020202020204" pitchFamily="34" charset="0"/>
+              </a:rPr>
+              <a:t>SliderController.php</a:t>
+            </a:r>
+            <a:r>
+              <a:rPr lang="az-Latn-AZ" altLang="en-US" sz="1100">
+                <a:latin typeface="Arial" panose="020B0604020202020204" pitchFamily="34" charset="0"/>
+              </a:rPr>
+              <a:t>` class -ının, </a:t>
+            </a:r>
+            <a:r>
+              <a:rPr lang="az-Latn-AZ" altLang="en-US" sz="1100" b="1">
+                <a:latin typeface="Arial" panose="020B0604020202020204" pitchFamily="34" charset="0"/>
+              </a:rPr>
+              <a:t>index() </a:t>
+            </a:r>
+            <a:r>
+              <a:rPr lang="az-Latn-AZ" altLang="en-US" sz="1100">
+                <a:latin typeface="Arial" panose="020B0604020202020204" pitchFamily="34" charset="0"/>
+              </a:rPr>
+              <a:t>metoduna əlavə edirik.</a:t>
+            </a:r>
+            <a:r>
+              <a:rPr lang="en-US" altLang="en-US" sz="1100">
+                <a:latin typeface="Arial" panose="020B0604020202020204" pitchFamily="34" charset="0"/>
+              </a:rPr>
+              <a:t> </a:t>
+            </a:r>
+            <a:r>
+              <a:rPr lang="az-Latn-AZ" altLang="en-US" sz="1100">
+                <a:latin typeface="Arial" panose="020B0604020202020204" pitchFamily="34" charset="0"/>
+              </a:rPr>
+              <a:t>Sonra isə, </a:t>
+            </a:r>
+            <a:r>
+              <a:rPr lang="az-Latn-AZ" altLang="en-US" sz="1100" b="1">
+                <a:latin typeface="Arial" panose="020B0604020202020204" pitchFamily="34" charset="0"/>
+              </a:rPr>
+              <a:t>Yajrabox</a:t>
+            </a:r>
+            <a:r>
+              <a:rPr lang="az-Latn-AZ" altLang="en-US" sz="1100">
+                <a:latin typeface="Arial" panose="020B0604020202020204" pitchFamily="34" charset="0"/>
+              </a:rPr>
+              <a:t> -un saytında olan addımları izləyərək, aşağı şəkildəki kimi, </a:t>
+            </a:r>
+            <a:r>
+              <a:rPr lang="az-Latn-AZ" altLang="en-US" sz="1100">
+                <a:solidFill>
+                  <a:srgbClr val="00B050"/>
+                </a:solidFill>
+                <a:latin typeface="Arial" panose="020B0604020202020204" pitchFamily="34" charset="0"/>
+              </a:rPr>
+              <a:t>elementləri</a:t>
+            </a:r>
+            <a:r>
+              <a:rPr lang="az-Latn-AZ" altLang="en-US" sz="1100">
+                <a:latin typeface="Arial" panose="020B0604020202020204" pitchFamily="34" charset="0"/>
+              </a:rPr>
+              <a:t> göstərilən qayda da, fayllara yazırıq.</a:t>
+            </a:r>
+            <a:endParaRPr lang="en-US" altLang="en-US" sz="1100">
+              <a:latin typeface="Arial" panose="020B0604020202020204" pitchFamily="34" charset="0"/>
+            </a:endParaRPr>
+          </a:p>
+        </p:txBody>
+      </p:sp>
+      <p:pic>
+        <p:nvPicPr>
+          <p:cNvPr id="4" name="Picture 3">
+            <a:extLst>
+              <a:ext uri="{FF2B5EF4-FFF2-40B4-BE49-F238E27FC236}">
+                <a16:creationId xmlns:a16="http://schemas.microsoft.com/office/drawing/2014/main" id="{9AD69973-3F43-AADA-DD0C-5000D0F8F708}"/>
+              </a:ext>
+            </a:extLst>
+          </p:cNvPr>
+          <p:cNvPicPr>
+            <a:picLocks noChangeAspect="1"/>
+          </p:cNvPicPr>
+          <p:nvPr/>
+        </p:nvPicPr>
+        <p:blipFill>
+          <a:blip r:embed="rId2"/>
+          <a:srcRect b="4390"/>
+          <a:stretch>
+            <a:fillRect/>
+          </a:stretch>
+        </p:blipFill>
+        <p:spPr>
+          <a:xfrm>
+            <a:off x="0" y="923873"/>
+            <a:ext cx="12192000" cy="5934127"/>
+          </a:xfrm>
+          <a:prstGeom prst="rect">
+            <a:avLst/>
+          </a:prstGeom>
+        </p:spPr>
+      </p:pic>
+    </p:spTree>
+    <p:extLst>
+      <p:ext uri="{BB962C8B-B14F-4D97-AF65-F5344CB8AC3E}">
+        <p14:creationId xmlns:p14="http://schemas.microsoft.com/office/powerpoint/2010/main" val="4263494882"/>
+      </p:ext>
+    </p:extLst>
+  </p:cSld>
+  <p:clrMapOvr>
+    <a:masterClrMapping/>
+  </p:clrMapOvr>
+</p:sld>
+</file>
+
+<file path=ppt/slides/slide7.xml><?xml version="1.0" encoding="utf-8"?>
+<p:sld xmlns:a="http://schemas.openxmlformats.org/drawingml/2006/main" xmlns:r="http://schemas.openxmlformats.org/officeDocument/2006/relationships" xmlns:p="http://schemas.openxmlformats.org/presentationml/2006/main">
+  <p:cSld>
+    <p:spTree>
+      <p:nvGrpSpPr>
+        <p:cNvPr id="1" name="">
+          <a:extLst>
+            <a:ext uri="{FF2B5EF4-FFF2-40B4-BE49-F238E27FC236}">
+              <a16:creationId xmlns:a16="http://schemas.microsoft.com/office/drawing/2014/main" id="{6FFB6D32-0208-D2D0-C878-F62245A03F18}"/>
+            </a:ext>
+          </a:extLst>
+        </p:cNvPr>
+        <p:cNvGrpSpPr/>
+        <p:nvPr/>
+      </p:nvGrpSpPr>
+      <p:grpSpPr>
+        <a:xfrm>
+          <a:off x="0" y="0"/>
+          <a:ext cx="0" cy="0"/>
+          <a:chOff x="0" y="0"/>
+          <a:chExt cx="0" cy="0"/>
+        </a:xfrm>
+      </p:grpSpPr>
+      <p:sp>
+        <p:nvSpPr>
+          <p:cNvPr id="3" name="TextBox 2">
+            <a:extLst>
+              <a:ext uri="{FF2B5EF4-FFF2-40B4-BE49-F238E27FC236}">
+                <a16:creationId xmlns:a16="http://schemas.microsoft.com/office/drawing/2014/main" id="{224E50B3-082E-656D-089B-67C95F26251E}"/>
+              </a:ext>
+            </a:extLst>
+          </p:cNvPr>
+          <p:cNvSpPr txBox="1"/>
+          <p:nvPr/>
+        </p:nvSpPr>
+        <p:spPr>
+          <a:xfrm>
+            <a:off x="217714" y="255046"/>
+            <a:ext cx="11756571" cy="955518"/>
+          </a:xfrm>
+          <a:prstGeom prst="rect">
+            <a:avLst/>
+          </a:prstGeom>
+          <a:noFill/>
+        </p:spPr>
+        <p:txBody>
+          <a:bodyPr wrap="square">
+            <a:spAutoFit/>
+          </a:bodyPr>
+          <a:lstStyle/>
+          <a:p>
+            <a:pPr>
+              <a:lnSpc>
+                <a:spcPct val="150000"/>
+              </a:lnSpc>
+              <a:buNone/>
+            </a:pPr>
+            <a:r>
+              <a:rPr lang="az-Latn-AZ" altLang="en-US" sz="1300">
+                <a:latin typeface="Arial" panose="020B0604020202020204" pitchFamily="34" charset="0"/>
+              </a:rPr>
+              <a:t>Nəticə.</a:t>
+            </a:r>
+          </a:p>
+          <a:p>
+            <a:pPr>
+              <a:lnSpc>
+                <a:spcPct val="150000"/>
+              </a:lnSpc>
+              <a:buNone/>
+            </a:pPr>
+            <a:endParaRPr kumimoji="0" lang="az-Latn-AZ" altLang="en-US" sz="1300" b="0" i="0" u="none" strike="noStrike" cap="none" normalizeH="0" baseline="0">
+              <a:ln>
+                <a:noFill/>
+              </a:ln>
+              <a:solidFill>
+                <a:schemeClr val="tx1"/>
+              </a:solidFill>
+              <a:effectLst/>
+              <a:latin typeface="Arial" panose="020B0604020202020204" pitchFamily="34" charset="0"/>
+            </a:endParaRPr>
+          </a:p>
+          <a:p>
+            <a:pPr>
+              <a:lnSpc>
+                <a:spcPct val="150000"/>
+              </a:lnSpc>
+              <a:buNone/>
+            </a:pPr>
+            <a:r>
+              <a:rPr lang="az-Latn-AZ" altLang="en-US" sz="1300">
+                <a:latin typeface="Arial" panose="020B0604020202020204" pitchFamily="34" charset="0"/>
+              </a:rPr>
+              <a:t>Ancaq stil olaraq səliqəsizdir.</a:t>
+            </a:r>
+            <a:endParaRPr kumimoji="0" lang="en-US" altLang="en-US" sz="1300" b="0" i="0" u="none" strike="noStrike" cap="none" normalizeH="0" baseline="0">
+              <a:ln>
+                <a:noFill/>
+              </a:ln>
+              <a:solidFill>
+                <a:schemeClr val="tx1"/>
+              </a:solidFill>
+              <a:effectLst/>
+              <a:latin typeface="Arial" panose="020B0604020202020204" pitchFamily="34" charset="0"/>
+            </a:endParaRPr>
+          </a:p>
+        </p:txBody>
+      </p:sp>
+      <p:pic>
+        <p:nvPicPr>
+          <p:cNvPr id="4" name="Picture 3">
+            <a:extLst>
+              <a:ext uri="{FF2B5EF4-FFF2-40B4-BE49-F238E27FC236}">
+                <a16:creationId xmlns:a16="http://schemas.microsoft.com/office/drawing/2014/main" id="{FFE79EDB-8D1E-218E-CA13-63ED35BE5218}"/>
+              </a:ext>
+            </a:extLst>
+          </p:cNvPr>
+          <p:cNvPicPr>
+            <a:picLocks noChangeAspect="1"/>
+          </p:cNvPicPr>
+          <p:nvPr/>
+        </p:nvPicPr>
+        <p:blipFill>
+          <a:blip r:embed="rId2"/>
+          <a:stretch>
+            <a:fillRect/>
+          </a:stretch>
+        </p:blipFill>
+        <p:spPr>
+          <a:xfrm>
+            <a:off x="0" y="2700477"/>
+            <a:ext cx="12192000" cy="4157523"/>
+          </a:xfrm>
+          <a:prstGeom prst="rect">
+            <a:avLst/>
+          </a:prstGeom>
+          <a:ln w="38100" cap="sq">
+            <a:solidFill>
+              <a:srgbClr val="000000"/>
+            </a:solidFill>
+            <a:prstDash val="solid"/>
+            <a:miter lim="800000"/>
+          </a:ln>
+          <a:effectLst>
+            <a:outerShdw blurRad="50800" dist="38100" dir="2700000" algn="tl" rotWithShape="0">
+              <a:srgbClr val="000000">
+                <a:alpha val="43000"/>
+              </a:srgbClr>
+            </a:outerShdw>
+          </a:effectLst>
+        </p:spPr>
+      </p:pic>
+    </p:spTree>
+    <p:extLst>
+      <p:ext uri="{BB962C8B-B14F-4D97-AF65-F5344CB8AC3E}">
+        <p14:creationId xmlns:p14="http://schemas.microsoft.com/office/powerpoint/2010/main" val="4190133311"/>
+      </p:ext>
+    </p:extLst>
+  </p:cSld>
+  <p:clrMapOvr>
+    <a:masterClrMapping/>
+  </p:clrMapOvr>
+</p:sld>
+</file>
+
+<file path=ppt/slides/slide8.xml><?xml version="1.0" encoding="utf-8"?>
+<p:sld xmlns:a="http://schemas.openxmlformats.org/drawingml/2006/main" xmlns:r="http://schemas.openxmlformats.org/officeDocument/2006/relationships" xmlns:p="http://schemas.openxmlformats.org/presentationml/2006/main">
+  <p:cSld>
+    <p:spTree>
+      <p:nvGrpSpPr>
+        <p:cNvPr id="1" name="">
+          <a:extLst>
+            <a:ext uri="{FF2B5EF4-FFF2-40B4-BE49-F238E27FC236}">
+              <a16:creationId xmlns:a16="http://schemas.microsoft.com/office/drawing/2014/main" id="{6882B1E7-48A3-BA39-404B-C49B7AAC6EAC}"/>
+            </a:ext>
+          </a:extLst>
+        </p:cNvPr>
+        <p:cNvGrpSpPr/>
+        <p:nvPr/>
+      </p:nvGrpSpPr>
+      <p:grpSpPr>
+        <a:xfrm>
+          <a:off x="0" y="0"/>
+          <a:ext cx="0" cy="0"/>
+          <a:chOff x="0" y="0"/>
+          <a:chExt cx="0" cy="0"/>
+        </a:xfrm>
+      </p:grpSpPr>
+      <p:sp>
+        <p:nvSpPr>
+          <p:cNvPr id="3" name="TextBox 2">
+            <a:extLst>
+              <a:ext uri="{FF2B5EF4-FFF2-40B4-BE49-F238E27FC236}">
+                <a16:creationId xmlns:a16="http://schemas.microsoft.com/office/drawing/2014/main" id="{245B6559-4506-B34E-24F5-756D0C0693B1}"/>
+              </a:ext>
+            </a:extLst>
+          </p:cNvPr>
+          <p:cNvSpPr txBox="1"/>
+          <p:nvPr/>
+        </p:nvSpPr>
+        <p:spPr>
+          <a:xfrm>
+            <a:off x="217714" y="255046"/>
+            <a:ext cx="11756571" cy="655436"/>
+          </a:xfrm>
+          <a:prstGeom prst="rect">
+            <a:avLst/>
+          </a:prstGeom>
+          <a:noFill/>
+        </p:spPr>
+        <p:txBody>
+          <a:bodyPr wrap="square">
+            <a:spAutoFit/>
+          </a:bodyPr>
+          <a:lstStyle/>
+          <a:p>
+            <a:pPr>
+              <a:lnSpc>
+                <a:spcPct val="150000"/>
+              </a:lnSpc>
+              <a:buNone/>
+            </a:pPr>
+            <a:r>
+              <a:rPr lang="az-Latn-AZ" altLang="en-US" sz="1300">
+                <a:latin typeface="Arial" panose="020B0604020202020204" pitchFamily="34" charset="0"/>
+              </a:rPr>
+              <a:t>Stilləri yükləyə bilmək üçün, keçid edirik `</a:t>
+            </a:r>
+            <a:r>
+              <a:rPr lang="az-Latn-AZ" altLang="en-US" sz="1300" b="1">
+                <a:latin typeface="Arial" panose="020B0604020202020204" pitchFamily="34" charset="0"/>
+              </a:rPr>
+              <a:t>Full Getting Started Guide</a:t>
+            </a:r>
+            <a:r>
+              <a:rPr lang="az-Latn-AZ" altLang="en-US" sz="1300">
+                <a:latin typeface="Arial" panose="020B0604020202020204" pitchFamily="34" charset="0"/>
+              </a:rPr>
+              <a:t>` səhifəsinə. Növbəti slaydda göstərilən addımları izləyərək, bəzi </a:t>
+            </a:r>
+            <a:r>
+              <a:rPr lang="az-Latn-AZ" altLang="en-US" sz="1300" b="1">
+                <a:latin typeface="Arial" panose="020B0604020202020204" pitchFamily="34" charset="0"/>
+              </a:rPr>
+              <a:t>css</a:t>
+            </a:r>
+            <a:r>
+              <a:rPr lang="az-Latn-AZ" altLang="en-US" sz="1300">
+                <a:latin typeface="Arial" panose="020B0604020202020204" pitchFamily="34" charset="0"/>
+              </a:rPr>
+              <a:t> və </a:t>
+            </a:r>
+            <a:r>
+              <a:rPr lang="az-Latn-AZ" altLang="en-US" sz="1300" b="1">
+                <a:latin typeface="Arial" panose="020B0604020202020204" pitchFamily="34" charset="0"/>
+              </a:rPr>
+              <a:t>js</a:t>
+            </a:r>
+            <a:r>
+              <a:rPr lang="az-Latn-AZ" altLang="en-US" sz="1300">
+                <a:latin typeface="Arial" panose="020B0604020202020204" pitchFamily="34" charset="0"/>
+              </a:rPr>
+              <a:t> linklərini `</a:t>
+            </a:r>
+            <a:r>
+              <a:rPr lang="en-US" altLang="en-US" sz="1300" b="1">
+                <a:latin typeface="Arial" panose="020B0604020202020204" pitchFamily="34" charset="0"/>
+              </a:rPr>
+              <a:t>resources\views\admin\layouts\</a:t>
+            </a:r>
+            <a:r>
+              <a:rPr lang="en-US" altLang="en-US" sz="1300" b="1" u="sng">
+                <a:latin typeface="Arial" panose="020B0604020202020204" pitchFamily="34" charset="0"/>
+              </a:rPr>
+              <a:t>master.blade.php</a:t>
+            </a:r>
+            <a:r>
+              <a:rPr lang="az-Latn-AZ" altLang="en-US" sz="1300">
+                <a:latin typeface="Arial" panose="020B0604020202020204" pitchFamily="34" charset="0"/>
+              </a:rPr>
+              <a:t>` faylına əlavə etmək lazımdır.</a:t>
+            </a:r>
+            <a:endParaRPr kumimoji="0" lang="en-US" altLang="en-US" sz="1300" b="0" i="0" u="none" strike="noStrike" cap="none" normalizeH="0" baseline="0">
+              <a:ln>
+                <a:noFill/>
+              </a:ln>
+              <a:solidFill>
+                <a:schemeClr val="tx1"/>
+              </a:solidFill>
+              <a:effectLst/>
+              <a:latin typeface="Arial" panose="020B0604020202020204" pitchFamily="34" charset="0"/>
+            </a:endParaRPr>
+          </a:p>
+        </p:txBody>
+      </p:sp>
+      <p:pic>
+        <p:nvPicPr>
+          <p:cNvPr id="4" name="Picture 3">
+            <a:extLst>
+              <a:ext uri="{FF2B5EF4-FFF2-40B4-BE49-F238E27FC236}">
+                <a16:creationId xmlns:a16="http://schemas.microsoft.com/office/drawing/2014/main" id="{6318BD49-B2A6-A03B-4EF8-FA27DD09E980}"/>
+              </a:ext>
+            </a:extLst>
+          </p:cNvPr>
+          <p:cNvPicPr>
+            <a:picLocks noChangeAspect="1"/>
+          </p:cNvPicPr>
+          <p:nvPr/>
+        </p:nvPicPr>
+        <p:blipFill>
+          <a:blip r:embed="rId2"/>
+          <a:stretch>
+            <a:fillRect/>
+          </a:stretch>
+        </p:blipFill>
+        <p:spPr>
+          <a:xfrm>
+            <a:off x="-1" y="1686407"/>
+            <a:ext cx="12192000" cy="5171593"/>
+          </a:xfrm>
+          <a:prstGeom prst="rect">
+            <a:avLst/>
+          </a:prstGeom>
+        </p:spPr>
+      </p:pic>
+    </p:spTree>
+    <p:extLst>
+      <p:ext uri="{BB962C8B-B14F-4D97-AF65-F5344CB8AC3E}">
+        <p14:creationId xmlns:p14="http://schemas.microsoft.com/office/powerpoint/2010/main" val="2574890678"/>
+      </p:ext>
+    </p:extLst>
+  </p:cSld>
+  <p:clrMapOvr>
+    <a:masterClrMapping/>
+  </p:clrMapOvr>
+</p:sld>
+</file>
+
+<file path=ppt/slides/slide9.xml><?xml version="1.0" encoding="utf-8"?>
+<p:sld xmlns:a="http://schemas.openxmlformats.org/drawingml/2006/main" xmlns:r="http://schemas.openxmlformats.org/officeDocument/2006/relationships" xmlns:p="http://schemas.openxmlformats.org/presentationml/2006/main">
+  <p:cSld>
+    <p:spTree>
+      <p:nvGrpSpPr>
+        <p:cNvPr id="1" name="">
+          <a:extLst>
+            <a:ext uri="{FF2B5EF4-FFF2-40B4-BE49-F238E27FC236}">
+              <a16:creationId xmlns:a16="http://schemas.microsoft.com/office/drawing/2014/main" id="{A806F425-B98B-C25B-A95C-45DE6B02DF67}"/>
+            </a:ext>
+          </a:extLst>
+        </p:cNvPr>
+        <p:cNvGrpSpPr/>
+        <p:nvPr/>
+      </p:nvGrpSpPr>
+      <p:grpSpPr>
+        <a:xfrm>
+          <a:off x="0" y="0"/>
+          <a:ext cx="0" cy="0"/>
+          <a:chOff x="0" y="0"/>
+          <a:chExt cx="0" cy="0"/>
+        </a:xfrm>
+      </p:grpSpPr>
+      <p:sp>
+        <p:nvSpPr>
+          <p:cNvPr id="3" name="TextBox 2">
+            <a:extLst>
+              <a:ext uri="{FF2B5EF4-FFF2-40B4-BE49-F238E27FC236}">
+                <a16:creationId xmlns:a16="http://schemas.microsoft.com/office/drawing/2014/main" id="{5671721B-6C98-27D9-CFDB-6CC17A3336EC}"/>
               </a:ext>
             </a:extLst>
           </p:cNvPr>
@@ -3556,10 +6005,40 @@
           </a:p>
         </p:txBody>
       </p:sp>
+      <p:pic>
+        <p:nvPicPr>
+          <p:cNvPr id="6" name="Picture 5">
+            <a:extLst>
+              <a:ext uri="{FF2B5EF4-FFF2-40B4-BE49-F238E27FC236}">
+                <a16:creationId xmlns:a16="http://schemas.microsoft.com/office/drawing/2014/main" id="{9D53919A-652A-A191-453E-8C8766E585DB}"/>
+              </a:ext>
+            </a:extLst>
+          </p:cNvPr>
+          <p:cNvPicPr>
+            <a:picLocks noChangeAspect="1"/>
+          </p:cNvPicPr>
+          <p:nvPr/>
+        </p:nvPicPr>
+        <p:blipFill>
+          <a:blip r:embed="rId2"/>
+          <a:stretch>
+            <a:fillRect/>
+          </a:stretch>
+        </p:blipFill>
+        <p:spPr>
+          <a:xfrm>
+            <a:off x="1298251" y="0"/>
+            <a:ext cx="10893749" cy="6858000"/>
+          </a:xfrm>
+          <a:prstGeom prst="rect">
+            <a:avLst/>
+          </a:prstGeom>
+        </p:spPr>
+      </p:pic>
     </p:spTree>
     <p:extLst>
       <p:ext uri="{BB962C8B-B14F-4D97-AF65-F5344CB8AC3E}">
-        <p14:creationId xmlns:p14="http://schemas.microsoft.com/office/powerpoint/2010/main" val="3095838342"/>
+        <p14:creationId xmlns:p14="http://schemas.microsoft.com/office/powerpoint/2010/main" val="1954859903"/>
       </p:ext>
     </p:extLst>
   </p:cSld>

</xml_diff>